<commit_message>
feat(voice): always-on wake word 'ya basira' with auto restart
</commit_message>
<xml_diff>
--- a/docs/Basira-Presentation.pptx
+++ b/docs/Basira-Presentation.pptx
@@ -16,6 +16,9 @@
     <p:sldId id="264" r:id="rId15"/>
     <p:sldId id="265" r:id="rId16"/>
     <p:sldId id="266" r:id="rId17"/>
+    <p:sldId id="268" r:id="rId19"/>
+    <p:sldId id="269" r:id="rId20"/>
+    <p:sldId id="270" r:id="rId21"/>
     <p:sldId id="267" r:id="rId18"/>
   </p:sldIdLst>
   <p:sldSz cx="12191695" cy="6858000" type="screen4x3"/>
@@ -5599,6 +5602,3010 @@
                 <a:latin typeface="Segoe UI"/>
               </a:rPr>
               <a:t>MIT License © 2026 Basira</a:t>
+            </a:r>
+          </a:p>
+        </p:txBody>
+      </p:sp>
+    </p:spTree>
+  </p:cSld>
+  <p:clrMapOvr>
+    <a:masterClrMapping/>
+  </p:clrMapOvr>
+</p:sld>
+</file>
+
+<file path=ppt/slides/slide13.xml><?xml version="1.0" encoding="utf-8"?>
+<p:sld xmlns:a="http://schemas.openxmlformats.org/drawingml/2006/main" xmlns:p="http://schemas.openxmlformats.org/presentationml/2006/main" xmlns:r="http://schemas.openxmlformats.org/officeDocument/2006/relationships">
+  <p:cSld>
+    <p:spTree>
+      <p:nvGrpSpPr>
+        <p:cNvPr id="1" name=""/>
+        <p:cNvGrpSpPr/>
+        <p:nvPr/>
+      </p:nvGrpSpPr>
+      <p:grpSpPr/>
+      <p:sp>
+        <p:nvSpPr>
+          <p:cNvPr id="2" name="Rectangle 1"/>
+          <p:cNvSpPr/>
+          <p:nvPr/>
+        </p:nvSpPr>
+        <p:spPr>
+          <a:xfrm>
+            <a:off x="0" y="0"/>
+            <a:ext cx="12191695" cy="146304"/>
+          </a:xfrm>
+          <a:prstGeom prst="rect">
+            <a:avLst/>
+          </a:prstGeom>
+          <a:solidFill>
+            <a:srgbClr val="0B6B3A"/>
+          </a:solidFill>
+          <a:ln>
+            <a:noFill/>
+          </a:ln>
+          <a:effectLst/>
+        </p:spPr>
+        <p:style>
+          <a:lnRef idx="1">
+            <a:schemeClr val="accent1"/>
+          </a:lnRef>
+          <a:fillRef idx="3">
+            <a:schemeClr val="accent1"/>
+          </a:fillRef>
+          <a:effectRef idx="2">
+            <a:schemeClr val="accent1"/>
+          </a:effectRef>
+          <a:fontRef idx="minor">
+            <a:schemeClr val="lt1"/>
+          </a:fontRef>
+        </p:style>
+        <p:txBody>
+          <a:bodyPr rtlCol="0" anchor="ctr"/>
+          <a:lstStyle/>
+          <a:p>
+            <a:pPr algn="ctr"/>
+          </a:p>
+        </p:txBody>
+      </p:sp>
+      <p:sp>
+        <p:nvSpPr>
+          <p:cNvPr id="3" name="TextBox 2"/>
+          <p:cNvSpPr txBox="1"/>
+          <p:nvPr/>
+        </p:nvSpPr>
+        <p:spPr>
+          <a:xfrm>
+            <a:off x="640080" y="411480"/>
+            <a:ext cx="10972800" cy="365760"/>
+          </a:xfrm>
+          <a:prstGeom prst="rect">
+            <a:avLst/>
+          </a:prstGeom>
+          <a:noFill/>
+        </p:spPr>
+        <p:txBody>
+          <a:bodyPr wrap="square" anchor="t" lIns="0" rIns="0" tIns="0" bIns="0">
+            <a:spAutoFit/>
+          </a:bodyPr>
+          <a:lstStyle/>
+          <a:p>
+            <a:pPr algn="r" rtl="1">
+              <a:lnSpc>
+                <a:spcPct val="120000"/>
+              </a:lnSpc>
+            </a:pPr>
+            <a:r>
+              <a:rPr sz="1400" b="1">
+                <a:solidFill>
+                  <a:srgbClr val="F5A524"/>
+                </a:solidFill>
+                <a:latin typeface="Segoe UI"/>
+              </a:rPr>
+              <a:t>لقطة حقيقية من النسخة المنشورة</a:t>
+            </a:r>
+          </a:p>
+        </p:txBody>
+      </p:sp>
+      <p:sp>
+        <p:nvSpPr>
+          <p:cNvPr id="4" name="TextBox 3"/>
+          <p:cNvSpPr txBox="1"/>
+          <p:nvPr/>
+        </p:nvSpPr>
+        <p:spPr>
+          <a:xfrm>
+            <a:off x="640080" y="731520"/>
+            <a:ext cx="10972800" cy="822960"/>
+          </a:xfrm>
+          <a:prstGeom prst="rect">
+            <a:avLst/>
+          </a:prstGeom>
+          <a:noFill/>
+        </p:spPr>
+        <p:txBody>
+          <a:bodyPr wrap="square" anchor="t" lIns="0" rIns="0" tIns="0" bIns="0">
+            <a:spAutoFit/>
+          </a:bodyPr>
+          <a:lstStyle/>
+          <a:p>
+            <a:pPr algn="r" rtl="1">
+              <a:lnSpc>
+                <a:spcPct val="120000"/>
+              </a:lnSpc>
+            </a:pPr>
+            <a:r>
+              <a:rPr sz="3400" b="1">
+                <a:solidFill>
+                  <a:srgbClr val="101613"/>
+                </a:solidFill>
+                <a:latin typeface="Segoe UI"/>
+              </a:rPr>
+              <a:t>التطبيق كما هو الآن</a:t>
+            </a:r>
+          </a:p>
+        </p:txBody>
+      </p:sp>
+      <p:sp>
+        <p:nvSpPr>
+          <p:cNvPr id="5" name="Rectangle 4"/>
+          <p:cNvSpPr/>
+          <p:nvPr/>
+        </p:nvSpPr>
+        <p:spPr>
+          <a:xfrm>
+            <a:off x="10088575" y="1600200"/>
+            <a:ext cx="1463040" cy="54864"/>
+          </a:xfrm>
+          <a:prstGeom prst="rect">
+            <a:avLst/>
+          </a:prstGeom>
+          <a:solidFill>
+            <a:srgbClr val="0B6B3A"/>
+          </a:solidFill>
+          <a:ln>
+            <a:noFill/>
+          </a:ln>
+          <a:effectLst/>
+        </p:spPr>
+        <p:style>
+          <a:lnRef idx="1">
+            <a:schemeClr val="accent1"/>
+          </a:lnRef>
+          <a:fillRef idx="3">
+            <a:schemeClr val="accent1"/>
+          </a:fillRef>
+          <a:effectRef idx="2">
+            <a:schemeClr val="accent1"/>
+          </a:effectRef>
+          <a:fontRef idx="minor">
+            <a:schemeClr val="lt1"/>
+          </a:fontRef>
+        </p:style>
+        <p:txBody>
+          <a:bodyPr rtlCol="0" anchor="ctr"/>
+          <a:lstStyle/>
+          <a:p>
+            <a:pPr algn="ctr"/>
+          </a:p>
+        </p:txBody>
+      </p:sp>
+      <p:sp>
+        <p:nvSpPr>
+          <p:cNvPr id="6" name="Rounded Rectangle 5"/>
+          <p:cNvSpPr/>
+          <p:nvPr/>
+        </p:nvSpPr>
+        <p:spPr>
+          <a:xfrm>
+            <a:off x="7818120" y="1874519"/>
+            <a:ext cx="3749039" cy="4617720"/>
+          </a:xfrm>
+          <a:prstGeom prst="roundRect">
+            <a:avLst>
+              <a:gd name="adj" fmla="val 6000"/>
+            </a:avLst>
+          </a:prstGeom>
+          <a:solidFill>
+            <a:srgbClr val="064A28"/>
+          </a:solidFill>
+          <a:ln>
+            <a:noFill/>
+          </a:ln>
+          <a:effectLst/>
+        </p:spPr>
+        <p:style>
+          <a:lnRef idx="1">
+            <a:schemeClr val="accent1"/>
+          </a:lnRef>
+          <a:fillRef idx="3">
+            <a:schemeClr val="accent1"/>
+          </a:fillRef>
+          <a:effectRef idx="2">
+            <a:schemeClr val="accent1"/>
+          </a:effectRef>
+          <a:fontRef idx="minor">
+            <a:schemeClr val="lt1"/>
+          </a:fontRef>
+        </p:style>
+        <p:txBody>
+          <a:bodyPr rtlCol="0" anchor="ctr"/>
+          <a:lstStyle/>
+          <a:p>
+            <a:pPr algn="ctr"/>
+          </a:p>
+        </p:txBody>
+      </p:sp>
+      <p:pic>
+        <p:nvPicPr>
+          <p:cNvPr id="7" name="Picture 6" descr="app_screenshot.png"/>
+          <p:cNvPicPr>
+            <a:picLocks noChangeAspect="1"/>
+          </p:cNvPicPr>
+          <p:nvPr/>
+        </p:nvPicPr>
+        <p:blipFill>
+          <a:blip r:embed="rId2"/>
+          <a:stretch>
+            <a:fillRect/>
+          </a:stretch>
+        </p:blipFill>
+        <p:spPr>
+          <a:xfrm>
+            <a:off x="7955279" y="2011680"/>
+            <a:ext cx="3474720" cy="2658794"/>
+          </a:xfrm>
+          <a:prstGeom prst="rect">
+            <a:avLst/>
+          </a:prstGeom>
+        </p:spPr>
+      </p:pic>
+      <p:sp>
+        <p:nvSpPr>
+          <p:cNvPr id="8" name="Rectangle 7"/>
+          <p:cNvSpPr/>
+          <p:nvPr/>
+        </p:nvSpPr>
+        <p:spPr>
+          <a:xfrm>
+            <a:off x="640080" y="1965960"/>
+            <a:ext cx="73152" cy="868680"/>
+          </a:xfrm>
+          <a:prstGeom prst="rect">
+            <a:avLst/>
+          </a:prstGeom>
+          <a:solidFill>
+            <a:srgbClr val="F5A524"/>
+          </a:solidFill>
+          <a:ln>
+            <a:noFill/>
+          </a:ln>
+          <a:effectLst/>
+        </p:spPr>
+        <p:style>
+          <a:lnRef idx="1">
+            <a:schemeClr val="accent1"/>
+          </a:lnRef>
+          <a:fillRef idx="3">
+            <a:schemeClr val="accent1"/>
+          </a:fillRef>
+          <a:effectRef idx="2">
+            <a:schemeClr val="accent1"/>
+          </a:effectRef>
+          <a:fontRef idx="minor">
+            <a:schemeClr val="lt1"/>
+          </a:fontRef>
+        </p:style>
+        <p:txBody>
+          <a:bodyPr rtlCol="0" anchor="ctr"/>
+          <a:lstStyle/>
+          <a:p>
+            <a:pPr algn="ctr"/>
+          </a:p>
+        </p:txBody>
+      </p:sp>
+      <p:sp>
+        <p:nvSpPr>
+          <p:cNvPr id="9" name="TextBox 8"/>
+          <p:cNvSpPr txBox="1"/>
+          <p:nvPr/>
+        </p:nvSpPr>
+        <p:spPr>
+          <a:xfrm>
+            <a:off x="3108960" y="1965960"/>
+            <a:ext cx="4480560" cy="365760"/>
+          </a:xfrm>
+          <a:prstGeom prst="rect">
+            <a:avLst/>
+          </a:prstGeom>
+          <a:noFill/>
+        </p:spPr>
+        <p:txBody>
+          <a:bodyPr wrap="square" anchor="t" lIns="0" rIns="0" tIns="0" bIns="0">
+            <a:spAutoFit/>
+          </a:bodyPr>
+          <a:lstStyle/>
+          <a:p>
+            <a:pPr algn="r" rtl="1">
+              <a:lnSpc>
+                <a:spcPct val="120000"/>
+              </a:lnSpc>
+            </a:pPr>
+            <a:r>
+              <a:rPr sz="1900" b="1">
+                <a:solidFill>
+                  <a:srgbClr val="101613"/>
+                </a:solidFill>
+                <a:latin typeface="Segoe UI"/>
+              </a:rPr>
+              <a:t>زر واحد كبير</a:t>
+            </a:r>
+          </a:p>
+        </p:txBody>
+      </p:sp>
+      <p:sp>
+        <p:nvSpPr>
+          <p:cNvPr id="10" name="TextBox 9"/>
+          <p:cNvSpPr txBox="1"/>
+          <p:nvPr/>
+        </p:nvSpPr>
+        <p:spPr>
+          <a:xfrm>
+            <a:off x="914400" y="2350008"/>
+            <a:ext cx="6675120" cy="457200"/>
+          </a:xfrm>
+          <a:prstGeom prst="rect">
+            <a:avLst/>
+          </a:prstGeom>
+          <a:noFill/>
+        </p:spPr>
+        <p:txBody>
+          <a:bodyPr wrap="square" anchor="t" lIns="0" rIns="0" tIns="0" bIns="0">
+            <a:spAutoFit/>
+          </a:bodyPr>
+          <a:lstStyle/>
+          <a:p>
+            <a:pPr algn="r" rtl="1">
+              <a:lnSpc>
+                <a:spcPct val="120000"/>
+              </a:lnSpc>
+            </a:pPr>
+            <a:r>
+              <a:rPr sz="1400" b="0">
+                <a:solidFill>
+                  <a:srgbClr val="5B6B63"/>
+                </a:solidFill>
+                <a:latin typeface="Segoe UI"/>
+              </a:rPr>
+              <a:t>«ابدأ المشي» — لا قوائم ولا خطوات وسيطة</a:t>
+            </a:r>
+          </a:p>
+        </p:txBody>
+      </p:sp>
+      <p:sp>
+        <p:nvSpPr>
+          <p:cNvPr id="11" name="Rectangle 10"/>
+          <p:cNvSpPr/>
+          <p:nvPr/>
+        </p:nvSpPr>
+        <p:spPr>
+          <a:xfrm>
+            <a:off x="640080" y="3017520"/>
+            <a:ext cx="73152" cy="868680"/>
+          </a:xfrm>
+          <a:prstGeom prst="rect">
+            <a:avLst/>
+          </a:prstGeom>
+          <a:solidFill>
+            <a:srgbClr val="F5A524"/>
+          </a:solidFill>
+          <a:ln>
+            <a:noFill/>
+          </a:ln>
+          <a:effectLst/>
+        </p:spPr>
+        <p:style>
+          <a:lnRef idx="1">
+            <a:schemeClr val="accent1"/>
+          </a:lnRef>
+          <a:fillRef idx="3">
+            <a:schemeClr val="accent1"/>
+          </a:fillRef>
+          <a:effectRef idx="2">
+            <a:schemeClr val="accent1"/>
+          </a:effectRef>
+          <a:fontRef idx="minor">
+            <a:schemeClr val="lt1"/>
+          </a:fontRef>
+        </p:style>
+        <p:txBody>
+          <a:bodyPr rtlCol="0" anchor="ctr"/>
+          <a:lstStyle/>
+          <a:p>
+            <a:pPr algn="ctr"/>
+          </a:p>
+        </p:txBody>
+      </p:sp>
+      <p:sp>
+        <p:nvSpPr>
+          <p:cNvPr id="12" name="TextBox 11"/>
+          <p:cNvSpPr txBox="1"/>
+          <p:nvPr/>
+        </p:nvSpPr>
+        <p:spPr>
+          <a:xfrm>
+            <a:off x="3108960" y="3017520"/>
+            <a:ext cx="4480560" cy="365760"/>
+          </a:xfrm>
+          <a:prstGeom prst="rect">
+            <a:avLst/>
+          </a:prstGeom>
+          <a:noFill/>
+        </p:spPr>
+        <p:txBody>
+          <a:bodyPr wrap="square" anchor="t" lIns="0" rIns="0" tIns="0" bIns="0">
+            <a:spAutoFit/>
+          </a:bodyPr>
+          <a:lstStyle/>
+          <a:p>
+            <a:pPr algn="r" rtl="1">
+              <a:lnSpc>
+                <a:spcPct val="120000"/>
+              </a:lnSpc>
+            </a:pPr>
+            <a:r>
+              <a:rPr sz="1900" b="1">
+                <a:solidFill>
+                  <a:srgbClr val="101613"/>
+                </a:solidFill>
+                <a:latin typeface="Segoe UI"/>
+              </a:rPr>
+              <a:t>حالة مسموعة</a:t>
+            </a:r>
+          </a:p>
+        </p:txBody>
+      </p:sp>
+      <p:sp>
+        <p:nvSpPr>
+          <p:cNvPr id="13" name="TextBox 12"/>
+          <p:cNvSpPr txBox="1"/>
+          <p:nvPr/>
+        </p:nvSpPr>
+        <p:spPr>
+          <a:xfrm>
+            <a:off x="914400" y="3401568"/>
+            <a:ext cx="6675120" cy="457200"/>
+          </a:xfrm>
+          <a:prstGeom prst="rect">
+            <a:avLst/>
+          </a:prstGeom>
+          <a:noFill/>
+        </p:spPr>
+        <p:txBody>
+          <a:bodyPr wrap="square" anchor="t" lIns="0" rIns="0" tIns="0" bIns="0">
+            <a:spAutoFit/>
+          </a:bodyPr>
+          <a:lstStyle/>
+          <a:p>
+            <a:pPr algn="r" rtl="1">
+              <a:lnSpc>
+                <a:spcPct val="120000"/>
+              </a:lnSpc>
+            </a:pPr>
+            <a:r>
+              <a:rPr sz="1400" b="0">
+                <a:solidFill>
+                  <a:srgbClr val="5B6B63"/>
+                </a:solidFill>
+                <a:latin typeface="Segoe UI"/>
+              </a:rPr>
+              <a:t>اضغط سطر الحالة ليُقرأ لك: الموقع، الاتصال، البلاغات</a:t>
+            </a:r>
+          </a:p>
+        </p:txBody>
+      </p:sp>
+      <p:sp>
+        <p:nvSpPr>
+          <p:cNvPr id="14" name="Rectangle 13"/>
+          <p:cNvSpPr/>
+          <p:nvPr/>
+        </p:nvSpPr>
+        <p:spPr>
+          <a:xfrm>
+            <a:off x="640080" y="4069080"/>
+            <a:ext cx="73152" cy="868680"/>
+          </a:xfrm>
+          <a:prstGeom prst="rect">
+            <a:avLst/>
+          </a:prstGeom>
+          <a:solidFill>
+            <a:srgbClr val="F5A524"/>
+          </a:solidFill>
+          <a:ln>
+            <a:noFill/>
+          </a:ln>
+          <a:effectLst/>
+        </p:spPr>
+        <p:style>
+          <a:lnRef idx="1">
+            <a:schemeClr val="accent1"/>
+          </a:lnRef>
+          <a:fillRef idx="3">
+            <a:schemeClr val="accent1"/>
+          </a:fillRef>
+          <a:effectRef idx="2">
+            <a:schemeClr val="accent1"/>
+          </a:effectRef>
+          <a:fontRef idx="minor">
+            <a:schemeClr val="lt1"/>
+          </a:fontRef>
+        </p:style>
+        <p:txBody>
+          <a:bodyPr rtlCol="0" anchor="ctr"/>
+          <a:lstStyle/>
+          <a:p>
+            <a:pPr algn="ctr"/>
+          </a:p>
+        </p:txBody>
+      </p:sp>
+      <p:sp>
+        <p:nvSpPr>
+          <p:cNvPr id="15" name="TextBox 14"/>
+          <p:cNvSpPr txBox="1"/>
+          <p:nvPr/>
+        </p:nvSpPr>
+        <p:spPr>
+          <a:xfrm>
+            <a:off x="3108960" y="4069080"/>
+            <a:ext cx="4480560" cy="365760"/>
+          </a:xfrm>
+          <a:prstGeom prst="rect">
+            <a:avLst/>
+          </a:prstGeom>
+          <a:noFill/>
+        </p:spPr>
+        <p:txBody>
+          <a:bodyPr wrap="square" anchor="t" lIns="0" rIns="0" tIns="0" bIns="0">
+            <a:spAutoFit/>
+          </a:bodyPr>
+          <a:lstStyle/>
+          <a:p>
+            <a:pPr algn="r" rtl="1">
+              <a:lnSpc>
+                <a:spcPct val="120000"/>
+              </a:lnSpc>
+            </a:pPr>
+            <a:r>
+              <a:rPr sz="1900" b="1">
+                <a:solidFill>
+                  <a:srgbClr val="101613"/>
+                </a:solidFill>
+                <a:latin typeface="Segoe UI"/>
+              </a:rPr>
+              <a:t>استغاثة واضحة</a:t>
+            </a:r>
+          </a:p>
+        </p:txBody>
+      </p:sp>
+      <p:sp>
+        <p:nvSpPr>
+          <p:cNvPr id="16" name="TextBox 15"/>
+          <p:cNvSpPr txBox="1"/>
+          <p:nvPr/>
+        </p:nvSpPr>
+        <p:spPr>
+          <a:xfrm>
+            <a:off x="914400" y="4453128"/>
+            <a:ext cx="6675120" cy="457200"/>
+          </a:xfrm>
+          <a:prstGeom prst="rect">
+            <a:avLst/>
+          </a:prstGeom>
+          <a:noFill/>
+        </p:spPr>
+        <p:txBody>
+          <a:bodyPr wrap="square" anchor="t" lIns="0" rIns="0" tIns="0" bIns="0">
+            <a:spAutoFit/>
+          </a:bodyPr>
+          <a:lstStyle/>
+          <a:p>
+            <a:pPr algn="r" rtl="1">
+              <a:lnSpc>
+                <a:spcPct val="120000"/>
+              </a:lnSpc>
+            </a:pPr>
+            <a:r>
+              <a:rPr sz="1400" b="0">
+                <a:solidFill>
+                  <a:srgbClr val="5B6B63"/>
+                </a:solidFill>
+                <a:latin typeface="Segoe UI"/>
+              </a:rPr>
+              <a:t>أحمر، ثابت أسفل الشاشة، لا يختفي بالتمرير</a:t>
+            </a:r>
+          </a:p>
+        </p:txBody>
+      </p:sp>
+      <p:sp>
+        <p:nvSpPr>
+          <p:cNvPr id="17" name="Rectangle 16"/>
+          <p:cNvSpPr/>
+          <p:nvPr/>
+        </p:nvSpPr>
+        <p:spPr>
+          <a:xfrm>
+            <a:off x="640080" y="5120640"/>
+            <a:ext cx="73152" cy="868680"/>
+          </a:xfrm>
+          <a:prstGeom prst="rect">
+            <a:avLst/>
+          </a:prstGeom>
+          <a:solidFill>
+            <a:srgbClr val="F5A524"/>
+          </a:solidFill>
+          <a:ln>
+            <a:noFill/>
+          </a:ln>
+          <a:effectLst/>
+        </p:spPr>
+        <p:style>
+          <a:lnRef idx="1">
+            <a:schemeClr val="accent1"/>
+          </a:lnRef>
+          <a:fillRef idx="3">
+            <a:schemeClr val="accent1"/>
+          </a:fillRef>
+          <a:effectRef idx="2">
+            <a:schemeClr val="accent1"/>
+          </a:effectRef>
+          <a:fontRef idx="minor">
+            <a:schemeClr val="lt1"/>
+          </a:fontRef>
+        </p:style>
+        <p:txBody>
+          <a:bodyPr rtlCol="0" anchor="ctr"/>
+          <a:lstStyle/>
+          <a:p>
+            <a:pPr algn="ctr"/>
+          </a:p>
+        </p:txBody>
+      </p:sp>
+      <p:sp>
+        <p:nvSpPr>
+          <p:cNvPr id="18" name="TextBox 17"/>
+          <p:cNvSpPr txBox="1"/>
+          <p:nvPr/>
+        </p:nvSpPr>
+        <p:spPr>
+          <a:xfrm>
+            <a:off x="3108960" y="5120640"/>
+            <a:ext cx="4480560" cy="365760"/>
+          </a:xfrm>
+          <a:prstGeom prst="rect">
+            <a:avLst/>
+          </a:prstGeom>
+          <a:noFill/>
+        </p:spPr>
+        <p:txBody>
+          <a:bodyPr wrap="square" anchor="t" lIns="0" rIns="0" tIns="0" bIns="0">
+            <a:spAutoFit/>
+          </a:bodyPr>
+          <a:lstStyle/>
+          <a:p>
+            <a:pPr algn="r" rtl="1">
+              <a:lnSpc>
+                <a:spcPct val="120000"/>
+              </a:lnSpc>
+            </a:pPr>
+            <a:r>
+              <a:rPr sz="1900" b="1">
+                <a:solidFill>
+                  <a:srgbClr val="101613"/>
+                </a:solidFill>
+                <a:latin typeface="Segoe UI"/>
+              </a:rPr>
+              <a:t>أوفلاين</a:t>
+            </a:r>
+          </a:p>
+        </p:txBody>
+      </p:sp>
+      <p:sp>
+        <p:nvSpPr>
+          <p:cNvPr id="19" name="TextBox 18"/>
+          <p:cNvSpPr txBox="1"/>
+          <p:nvPr/>
+        </p:nvSpPr>
+        <p:spPr>
+          <a:xfrm>
+            <a:off x="914400" y="5504688"/>
+            <a:ext cx="6675120" cy="457200"/>
+          </a:xfrm>
+          <a:prstGeom prst="rect">
+            <a:avLst/>
+          </a:prstGeom>
+          <a:noFill/>
+        </p:spPr>
+        <p:txBody>
+          <a:bodyPr wrap="square" anchor="t" lIns="0" rIns="0" tIns="0" bIns="0">
+            <a:spAutoFit/>
+          </a:bodyPr>
+          <a:lstStyle/>
+          <a:p>
+            <a:pPr algn="r" rtl="1">
+              <a:lnSpc>
+                <a:spcPct val="120000"/>
+              </a:lnSpc>
+            </a:pPr>
+            <a:r>
+              <a:rPr sz="1400" b="0">
+                <a:solidFill>
+                  <a:srgbClr val="5B6B63"/>
+                </a:solidFill>
+                <a:latin typeface="Segoe UI"/>
+              </a:rPr>
+              <a:t>٤ بلاغات معلّقة تنتظر الشبكة — والتنقل يستمر</a:t>
+            </a:r>
+          </a:p>
+        </p:txBody>
+      </p:sp>
+      <p:sp>
+        <p:nvSpPr>
+          <p:cNvPr id="20" name="TextBox 19"/>
+          <p:cNvSpPr txBox="1"/>
+          <p:nvPr/>
+        </p:nvSpPr>
+        <p:spPr>
+          <a:xfrm>
+            <a:off x="640080" y="6355080"/>
+            <a:ext cx="6766560" cy="365760"/>
+          </a:xfrm>
+          <a:prstGeom prst="rect">
+            <a:avLst/>
+          </a:prstGeom>
+          <a:noFill/>
+        </p:spPr>
+        <p:txBody>
+          <a:bodyPr wrap="square" anchor="t" lIns="0" rIns="0" tIns="0" bIns="0">
+            <a:spAutoFit/>
+          </a:bodyPr>
+          <a:lstStyle/>
+          <a:p>
+            <a:pPr algn="r" rtl="1">
+              <a:lnSpc>
+                <a:spcPct val="120000"/>
+              </a:lnSpc>
+            </a:pPr>
+            <a:r>
+              <a:rPr sz="1300" b="1">
+                <a:solidFill>
+                  <a:srgbClr val="0B6B3A"/>
+                </a:solidFill>
+                <a:latin typeface="Segoe UI"/>
+              </a:rPr>
+              <a:t>التصميم داكن عالي التباين افتراضيًا — أريح للعين وللحالات المختلطة.</a:t>
+            </a:r>
+          </a:p>
+        </p:txBody>
+      </p:sp>
+    </p:spTree>
+  </p:cSld>
+  <p:clrMapOvr>
+    <a:masterClrMapping/>
+  </p:clrMapOvr>
+</p:sld>
+</file>
+
+<file path=ppt/slides/slide14.xml><?xml version="1.0" encoding="utf-8"?>
+<p:sld xmlns:a="http://schemas.openxmlformats.org/drawingml/2006/main" xmlns:p="http://schemas.openxmlformats.org/presentationml/2006/main" xmlns:r="http://schemas.openxmlformats.org/officeDocument/2006/relationships">
+  <p:cSld>
+    <p:spTree>
+      <p:nvGrpSpPr>
+        <p:cNvPr id="1" name=""/>
+        <p:cNvGrpSpPr/>
+        <p:nvPr/>
+      </p:nvGrpSpPr>
+      <p:grpSpPr/>
+      <p:sp>
+        <p:nvSpPr>
+          <p:cNvPr id="2" name="Rectangle 1"/>
+          <p:cNvSpPr/>
+          <p:nvPr/>
+        </p:nvSpPr>
+        <p:spPr>
+          <a:xfrm>
+            <a:off x="0" y="0"/>
+            <a:ext cx="12191695" cy="146304"/>
+          </a:xfrm>
+          <a:prstGeom prst="rect">
+            <a:avLst/>
+          </a:prstGeom>
+          <a:solidFill>
+            <a:srgbClr val="0B6B3A"/>
+          </a:solidFill>
+          <a:ln>
+            <a:noFill/>
+          </a:ln>
+          <a:effectLst/>
+        </p:spPr>
+        <p:style>
+          <a:lnRef idx="1">
+            <a:schemeClr val="accent1"/>
+          </a:lnRef>
+          <a:fillRef idx="3">
+            <a:schemeClr val="accent1"/>
+          </a:fillRef>
+          <a:effectRef idx="2">
+            <a:schemeClr val="accent1"/>
+          </a:effectRef>
+          <a:fontRef idx="minor">
+            <a:schemeClr val="lt1"/>
+          </a:fontRef>
+        </p:style>
+        <p:txBody>
+          <a:bodyPr rtlCol="0" anchor="ctr"/>
+          <a:lstStyle/>
+          <a:p>
+            <a:pPr algn="ctr"/>
+          </a:p>
+        </p:txBody>
+      </p:sp>
+      <p:sp>
+        <p:nvSpPr>
+          <p:cNvPr id="3" name="TextBox 2"/>
+          <p:cNvSpPr txBox="1"/>
+          <p:nvPr/>
+        </p:nvSpPr>
+        <p:spPr>
+          <a:xfrm>
+            <a:off x="640080" y="411480"/>
+            <a:ext cx="10972800" cy="365760"/>
+          </a:xfrm>
+          <a:prstGeom prst="rect">
+            <a:avLst/>
+          </a:prstGeom>
+          <a:noFill/>
+        </p:spPr>
+        <p:txBody>
+          <a:bodyPr wrap="square" anchor="t" lIns="0" rIns="0" tIns="0" bIns="0">
+            <a:spAutoFit/>
+          </a:bodyPr>
+          <a:lstStyle/>
+          <a:p>
+            <a:pPr algn="r" rtl="1">
+              <a:lnSpc>
+                <a:spcPct val="120000"/>
+              </a:lnSpc>
+            </a:pPr>
+            <a:r>
+              <a:rPr sz="1400" b="1">
+                <a:solidFill>
+                  <a:srgbClr val="F5A524"/>
+                </a:solidFill>
+                <a:latin typeface="Segoe UI"/>
+              </a:rPr>
+              <a:t>٣ دقائق أمام اللجنة</a:t>
+            </a:r>
+          </a:p>
+        </p:txBody>
+      </p:sp>
+      <p:sp>
+        <p:nvSpPr>
+          <p:cNvPr id="4" name="TextBox 3"/>
+          <p:cNvSpPr txBox="1"/>
+          <p:nvPr/>
+        </p:nvSpPr>
+        <p:spPr>
+          <a:xfrm>
+            <a:off x="640080" y="731520"/>
+            <a:ext cx="10972800" cy="822960"/>
+          </a:xfrm>
+          <a:prstGeom prst="rect">
+            <a:avLst/>
+          </a:prstGeom>
+          <a:noFill/>
+        </p:spPr>
+        <p:txBody>
+          <a:bodyPr wrap="square" anchor="t" lIns="0" rIns="0" tIns="0" bIns="0">
+            <a:spAutoFit/>
+          </a:bodyPr>
+          <a:lstStyle/>
+          <a:p>
+            <a:pPr algn="r" rtl="1">
+              <a:lnSpc>
+                <a:spcPct val="120000"/>
+              </a:lnSpc>
+            </a:pPr>
+            <a:r>
+              <a:rPr sz="3400" b="1">
+                <a:solidFill>
+                  <a:srgbClr val="101613"/>
+                </a:solidFill>
+                <a:latin typeface="Segoe UI"/>
+              </a:rPr>
+              <a:t>سيناريو العرض الحيّ</a:t>
+            </a:r>
+          </a:p>
+        </p:txBody>
+      </p:sp>
+      <p:sp>
+        <p:nvSpPr>
+          <p:cNvPr id="5" name="Rectangle 4"/>
+          <p:cNvSpPr/>
+          <p:nvPr/>
+        </p:nvSpPr>
+        <p:spPr>
+          <a:xfrm>
+            <a:off x="10088575" y="1600200"/>
+            <a:ext cx="1463040" cy="54864"/>
+          </a:xfrm>
+          <a:prstGeom prst="rect">
+            <a:avLst/>
+          </a:prstGeom>
+          <a:solidFill>
+            <a:srgbClr val="0B6B3A"/>
+          </a:solidFill>
+          <a:ln>
+            <a:noFill/>
+          </a:ln>
+          <a:effectLst/>
+        </p:spPr>
+        <p:style>
+          <a:lnRef idx="1">
+            <a:schemeClr val="accent1"/>
+          </a:lnRef>
+          <a:fillRef idx="3">
+            <a:schemeClr val="accent1"/>
+          </a:fillRef>
+          <a:effectRef idx="2">
+            <a:schemeClr val="accent1"/>
+          </a:effectRef>
+          <a:fontRef idx="minor">
+            <a:schemeClr val="lt1"/>
+          </a:fontRef>
+        </p:style>
+        <p:txBody>
+          <a:bodyPr rtlCol="0" anchor="ctr"/>
+          <a:lstStyle/>
+          <a:p>
+            <a:pPr algn="ctr"/>
+          </a:p>
+        </p:txBody>
+      </p:sp>
+      <p:sp>
+        <p:nvSpPr>
+          <p:cNvPr id="6" name="Rounded Rectangle 5"/>
+          <p:cNvSpPr/>
+          <p:nvPr/>
+        </p:nvSpPr>
+        <p:spPr>
+          <a:xfrm>
+            <a:off x="6309360" y="1920240"/>
+            <a:ext cx="5120640" cy="914400"/>
+          </a:xfrm>
+          <a:prstGeom prst="roundRect">
+            <a:avLst>
+              <a:gd name="adj" fmla="val 12000"/>
+            </a:avLst>
+          </a:prstGeom>
+          <a:solidFill>
+            <a:srgbClr val="F4F7F5"/>
+          </a:solidFill>
+          <a:ln w="12700">
+            <a:solidFill>
+              <a:srgbClr val="D8E2DC"/>
+            </a:solidFill>
+          </a:ln>
+          <a:effectLst/>
+        </p:spPr>
+        <p:style>
+          <a:lnRef idx="1">
+            <a:schemeClr val="accent1"/>
+          </a:lnRef>
+          <a:fillRef idx="3">
+            <a:schemeClr val="accent1"/>
+          </a:fillRef>
+          <a:effectRef idx="2">
+            <a:schemeClr val="accent1"/>
+          </a:effectRef>
+          <a:fontRef idx="minor">
+            <a:schemeClr val="lt1"/>
+          </a:fontRef>
+        </p:style>
+        <p:txBody>
+          <a:bodyPr rtlCol="0" anchor="ctr"/>
+          <a:lstStyle/>
+          <a:p>
+            <a:pPr algn="ctr"/>
+          </a:p>
+        </p:txBody>
+      </p:sp>
+      <p:sp>
+        <p:nvSpPr>
+          <p:cNvPr id="7" name="TextBox 6"/>
+          <p:cNvSpPr txBox="1"/>
+          <p:nvPr/>
+        </p:nvSpPr>
+        <p:spPr>
+          <a:xfrm>
+            <a:off x="10652760" y="2029968"/>
+            <a:ext cx="640080" cy="320040"/>
+          </a:xfrm>
+          <a:prstGeom prst="rect">
+            <a:avLst/>
+          </a:prstGeom>
+          <a:noFill/>
+        </p:spPr>
+        <p:txBody>
+          <a:bodyPr wrap="square" anchor="t" lIns="0" rIns="0" tIns="0" bIns="0">
+            <a:spAutoFit/>
+          </a:bodyPr>
+          <a:lstStyle/>
+          <a:p>
+            <a:pPr algn="l" rtl="1">
+              <a:lnSpc>
+                <a:spcPct val="120000"/>
+              </a:lnSpc>
+            </a:pPr>
+            <a:r>
+              <a:rPr sz="1300" b="1">
+                <a:solidFill>
+                  <a:srgbClr val="0B6B3A"/>
+                </a:solidFill>
+                <a:latin typeface="Segoe UI"/>
+              </a:rPr>
+              <a:t>٠:٠٠</a:t>
+            </a:r>
+          </a:p>
+        </p:txBody>
+      </p:sp>
+      <p:sp>
+        <p:nvSpPr>
+          <p:cNvPr id="8" name="TextBox 7"/>
+          <p:cNvSpPr txBox="1"/>
+          <p:nvPr/>
+        </p:nvSpPr>
+        <p:spPr>
+          <a:xfrm>
+            <a:off x="6473952" y="2029968"/>
+            <a:ext cx="4069080" cy="320040"/>
+          </a:xfrm>
+          <a:prstGeom prst="rect">
+            <a:avLst/>
+          </a:prstGeom>
+          <a:noFill/>
+        </p:spPr>
+        <p:txBody>
+          <a:bodyPr wrap="square" anchor="t" lIns="0" rIns="0" tIns="0" bIns="0">
+            <a:spAutoFit/>
+          </a:bodyPr>
+          <a:lstStyle/>
+          <a:p>
+            <a:pPr algn="r" rtl="1">
+              <a:lnSpc>
+                <a:spcPct val="120000"/>
+              </a:lnSpc>
+            </a:pPr>
+            <a:r>
+              <a:rPr sz="1700" b="1">
+                <a:solidFill>
+                  <a:srgbClr val="101613"/>
+                </a:solidFill>
+                <a:latin typeface="Segoe UI"/>
+              </a:rPr>
+              <a:t>أغمضوا أعينكم ٣٠ ثانية</a:t>
+            </a:r>
+          </a:p>
+        </p:txBody>
+      </p:sp>
+      <p:sp>
+        <p:nvSpPr>
+          <p:cNvPr id="9" name="TextBox 8"/>
+          <p:cNvSpPr txBox="1"/>
+          <p:nvPr/>
+        </p:nvSpPr>
+        <p:spPr>
+          <a:xfrm>
+            <a:off x="6473952" y="2377440"/>
+            <a:ext cx="4754880" cy="365760"/>
+          </a:xfrm>
+          <a:prstGeom prst="rect">
+            <a:avLst/>
+          </a:prstGeom>
+          <a:noFill/>
+        </p:spPr>
+        <p:txBody>
+          <a:bodyPr wrap="square" anchor="t" lIns="0" rIns="0" tIns="0" bIns="0">
+            <a:spAutoFit/>
+          </a:bodyPr>
+          <a:lstStyle/>
+          <a:p>
+            <a:pPr algn="r" rtl="1">
+              <a:lnSpc>
+                <a:spcPct val="120000"/>
+              </a:lnSpc>
+            </a:pPr>
+            <a:r>
+              <a:rPr sz="1200" b="0">
+                <a:solidFill>
+                  <a:srgbClr val="5B6B63"/>
+                </a:solidFill>
+                <a:latin typeface="Segoe UI"/>
+              </a:rPr>
+              <a:t>الإحساس بالمشكلة قبل أي شريحة</a:t>
+            </a:r>
+          </a:p>
+        </p:txBody>
+      </p:sp>
+      <p:sp>
+        <p:nvSpPr>
+          <p:cNvPr id="10" name="Rounded Rectangle 9"/>
+          <p:cNvSpPr/>
+          <p:nvPr/>
+        </p:nvSpPr>
+        <p:spPr>
+          <a:xfrm>
+            <a:off x="685800" y="1920240"/>
+            <a:ext cx="5120640" cy="914400"/>
+          </a:xfrm>
+          <a:prstGeom prst="roundRect">
+            <a:avLst>
+              <a:gd name="adj" fmla="val 12000"/>
+            </a:avLst>
+          </a:prstGeom>
+          <a:solidFill>
+            <a:srgbClr val="F4F7F5"/>
+          </a:solidFill>
+          <a:ln w="12700">
+            <a:solidFill>
+              <a:srgbClr val="D8E2DC"/>
+            </a:solidFill>
+          </a:ln>
+          <a:effectLst/>
+        </p:spPr>
+        <p:style>
+          <a:lnRef idx="1">
+            <a:schemeClr val="accent1"/>
+          </a:lnRef>
+          <a:fillRef idx="3">
+            <a:schemeClr val="accent1"/>
+          </a:fillRef>
+          <a:effectRef idx="2">
+            <a:schemeClr val="accent1"/>
+          </a:effectRef>
+          <a:fontRef idx="minor">
+            <a:schemeClr val="lt1"/>
+          </a:fontRef>
+        </p:style>
+        <p:txBody>
+          <a:bodyPr rtlCol="0" anchor="ctr"/>
+          <a:lstStyle/>
+          <a:p>
+            <a:pPr algn="ctr"/>
+          </a:p>
+        </p:txBody>
+      </p:sp>
+      <p:sp>
+        <p:nvSpPr>
+          <p:cNvPr id="11" name="TextBox 10"/>
+          <p:cNvSpPr txBox="1"/>
+          <p:nvPr/>
+        </p:nvSpPr>
+        <p:spPr>
+          <a:xfrm>
+            <a:off x="5029200" y="2029968"/>
+            <a:ext cx="640080" cy="320040"/>
+          </a:xfrm>
+          <a:prstGeom prst="rect">
+            <a:avLst/>
+          </a:prstGeom>
+          <a:noFill/>
+        </p:spPr>
+        <p:txBody>
+          <a:bodyPr wrap="square" anchor="t" lIns="0" rIns="0" tIns="0" bIns="0">
+            <a:spAutoFit/>
+          </a:bodyPr>
+          <a:lstStyle/>
+          <a:p>
+            <a:pPr algn="l" rtl="1">
+              <a:lnSpc>
+                <a:spcPct val="120000"/>
+              </a:lnSpc>
+            </a:pPr>
+            <a:r>
+              <a:rPr sz="1300" b="1">
+                <a:solidFill>
+                  <a:srgbClr val="0B6B3A"/>
+                </a:solidFill>
+                <a:latin typeface="Segoe UI"/>
+              </a:rPr>
+              <a:t>٠:٣٠</a:t>
+            </a:r>
+          </a:p>
+        </p:txBody>
+      </p:sp>
+      <p:sp>
+        <p:nvSpPr>
+          <p:cNvPr id="12" name="TextBox 11"/>
+          <p:cNvSpPr txBox="1"/>
+          <p:nvPr/>
+        </p:nvSpPr>
+        <p:spPr>
+          <a:xfrm>
+            <a:off x="850392" y="2029968"/>
+            <a:ext cx="4069080" cy="320040"/>
+          </a:xfrm>
+          <a:prstGeom prst="rect">
+            <a:avLst/>
+          </a:prstGeom>
+          <a:noFill/>
+        </p:spPr>
+        <p:txBody>
+          <a:bodyPr wrap="square" anchor="t" lIns="0" rIns="0" tIns="0" bIns="0">
+            <a:spAutoFit/>
+          </a:bodyPr>
+          <a:lstStyle/>
+          <a:p>
+            <a:pPr algn="r" rtl="1">
+              <a:lnSpc>
+                <a:spcPct val="120000"/>
+              </a:lnSpc>
+            </a:pPr>
+            <a:r>
+              <a:rPr sz="1700" b="1">
+                <a:solidFill>
+                  <a:srgbClr val="101613"/>
+                </a:solidFill>
+                <a:latin typeface="Segoe UI"/>
+              </a:rPr>
+              <a:t>افتح بصيرة</a:t>
+            </a:r>
+          </a:p>
+        </p:txBody>
+      </p:sp>
+      <p:sp>
+        <p:nvSpPr>
+          <p:cNvPr id="13" name="TextBox 12"/>
+          <p:cNvSpPr txBox="1"/>
+          <p:nvPr/>
+        </p:nvSpPr>
+        <p:spPr>
+          <a:xfrm>
+            <a:off x="850392" y="2377440"/>
+            <a:ext cx="4754880" cy="365760"/>
+          </a:xfrm>
+          <a:prstGeom prst="rect">
+            <a:avLst/>
+          </a:prstGeom>
+          <a:noFill/>
+        </p:spPr>
+        <p:txBody>
+          <a:bodyPr wrap="square" anchor="t" lIns="0" rIns="0" tIns="0" bIns="0">
+            <a:spAutoFit/>
+          </a:bodyPr>
+          <a:lstStyle/>
+          <a:p>
+            <a:pPr algn="r" rtl="1">
+              <a:lnSpc>
+                <a:spcPct val="120000"/>
+              </a:lnSpc>
+            </a:pPr>
+            <a:r>
+              <a:rPr sz="1200" b="0">
+                <a:solidFill>
+                  <a:srgbClr val="5B6B63"/>
+                </a:solidFill>
+                <a:latin typeface="Segoe UI"/>
+              </a:rPr>
+              <a:t>«طريقك الآمن بصوتك» — ثم إخلاء المسؤولية بثلاث نقاط</a:t>
+            </a:r>
+          </a:p>
+        </p:txBody>
+      </p:sp>
+      <p:sp>
+        <p:nvSpPr>
+          <p:cNvPr id="14" name="Rounded Rectangle 13"/>
+          <p:cNvSpPr/>
+          <p:nvPr/>
+        </p:nvSpPr>
+        <p:spPr>
+          <a:xfrm>
+            <a:off x="6309360" y="2999232"/>
+            <a:ext cx="5120640" cy="914400"/>
+          </a:xfrm>
+          <a:prstGeom prst="roundRect">
+            <a:avLst>
+              <a:gd name="adj" fmla="val 12000"/>
+            </a:avLst>
+          </a:prstGeom>
+          <a:solidFill>
+            <a:srgbClr val="F4F7F5"/>
+          </a:solidFill>
+          <a:ln w="12700">
+            <a:solidFill>
+              <a:srgbClr val="D8E2DC"/>
+            </a:solidFill>
+          </a:ln>
+          <a:effectLst/>
+        </p:spPr>
+        <p:style>
+          <a:lnRef idx="1">
+            <a:schemeClr val="accent1"/>
+          </a:lnRef>
+          <a:fillRef idx="3">
+            <a:schemeClr val="accent1"/>
+          </a:fillRef>
+          <a:effectRef idx="2">
+            <a:schemeClr val="accent1"/>
+          </a:effectRef>
+          <a:fontRef idx="minor">
+            <a:schemeClr val="lt1"/>
+          </a:fontRef>
+        </p:style>
+        <p:txBody>
+          <a:bodyPr rtlCol="0" anchor="ctr"/>
+          <a:lstStyle/>
+          <a:p>
+            <a:pPr algn="ctr"/>
+          </a:p>
+        </p:txBody>
+      </p:sp>
+      <p:sp>
+        <p:nvSpPr>
+          <p:cNvPr id="15" name="TextBox 14"/>
+          <p:cNvSpPr txBox="1"/>
+          <p:nvPr/>
+        </p:nvSpPr>
+        <p:spPr>
+          <a:xfrm>
+            <a:off x="10652760" y="3108960"/>
+            <a:ext cx="640080" cy="320040"/>
+          </a:xfrm>
+          <a:prstGeom prst="rect">
+            <a:avLst/>
+          </a:prstGeom>
+          <a:noFill/>
+        </p:spPr>
+        <p:txBody>
+          <a:bodyPr wrap="square" anchor="t" lIns="0" rIns="0" tIns="0" bIns="0">
+            <a:spAutoFit/>
+          </a:bodyPr>
+          <a:lstStyle/>
+          <a:p>
+            <a:pPr algn="l" rtl="1">
+              <a:lnSpc>
+                <a:spcPct val="120000"/>
+              </a:lnSpc>
+            </a:pPr>
+            <a:r>
+              <a:rPr sz="1300" b="1">
+                <a:solidFill>
+                  <a:srgbClr val="0B6B3A"/>
+                </a:solidFill>
+                <a:latin typeface="Segoe UI"/>
+              </a:rPr>
+              <a:t>٠:٥٠</a:t>
+            </a:r>
+          </a:p>
+        </p:txBody>
+      </p:sp>
+      <p:sp>
+        <p:nvSpPr>
+          <p:cNvPr id="16" name="TextBox 15"/>
+          <p:cNvSpPr txBox="1"/>
+          <p:nvPr/>
+        </p:nvSpPr>
+        <p:spPr>
+          <a:xfrm>
+            <a:off x="6473952" y="3108960"/>
+            <a:ext cx="4069080" cy="320040"/>
+          </a:xfrm>
+          <a:prstGeom prst="rect">
+            <a:avLst/>
+          </a:prstGeom>
+          <a:noFill/>
+        </p:spPr>
+        <p:txBody>
+          <a:bodyPr wrap="square" anchor="t" lIns="0" rIns="0" tIns="0" bIns="0">
+            <a:spAutoFit/>
+          </a:bodyPr>
+          <a:lstStyle/>
+          <a:p>
+            <a:pPr algn="r" rtl="1">
+              <a:lnSpc>
+                <a:spcPct val="120000"/>
+              </a:lnSpc>
+            </a:pPr>
+            <a:r>
+              <a:rPr sz="1700" b="1">
+                <a:solidFill>
+                  <a:srgbClr val="101613"/>
+                </a:solidFill>
+                <a:latin typeface="Segoe UI"/>
+              </a:rPr>
+              <a:t>«أين أنا؟»</a:t>
+            </a:r>
+          </a:p>
+        </p:txBody>
+      </p:sp>
+      <p:sp>
+        <p:nvSpPr>
+          <p:cNvPr id="17" name="TextBox 16"/>
+          <p:cNvSpPr txBox="1"/>
+          <p:nvPr/>
+        </p:nvSpPr>
+        <p:spPr>
+          <a:xfrm>
+            <a:off x="6473952" y="3456432"/>
+            <a:ext cx="4754880" cy="365760"/>
+          </a:xfrm>
+          <a:prstGeom prst="rect">
+            <a:avLst/>
+          </a:prstGeom>
+          <a:noFill/>
+        </p:spPr>
+        <p:txBody>
+          <a:bodyPr wrap="square" anchor="t" lIns="0" rIns="0" tIns="0" bIns="0">
+            <a:spAutoFit/>
+          </a:bodyPr>
+          <a:lstStyle/>
+          <a:p>
+            <a:pPr algn="r" rtl="1">
+              <a:lnSpc>
+                <a:spcPct val="120000"/>
+              </a:lnSpc>
+            </a:pPr>
+            <a:r>
+              <a:rPr sz="1200" b="0">
+                <a:solidFill>
+                  <a:srgbClr val="5B6B63"/>
+                </a:solidFill>
+                <a:latin typeface="Segoe UI"/>
+              </a:rPr>
+              <a:t>وصف الموقع وأقرب مبنى وإشارة</a:t>
+            </a:r>
+          </a:p>
+        </p:txBody>
+      </p:sp>
+      <p:sp>
+        <p:nvSpPr>
+          <p:cNvPr id="18" name="Rounded Rectangle 17"/>
+          <p:cNvSpPr/>
+          <p:nvPr/>
+        </p:nvSpPr>
+        <p:spPr>
+          <a:xfrm>
+            <a:off x="685800" y="2999232"/>
+            <a:ext cx="5120640" cy="914400"/>
+          </a:xfrm>
+          <a:prstGeom prst="roundRect">
+            <a:avLst>
+              <a:gd name="adj" fmla="val 12000"/>
+            </a:avLst>
+          </a:prstGeom>
+          <a:solidFill>
+            <a:srgbClr val="F4F7F5"/>
+          </a:solidFill>
+          <a:ln w="12700">
+            <a:solidFill>
+              <a:srgbClr val="D8E2DC"/>
+            </a:solidFill>
+          </a:ln>
+          <a:effectLst/>
+        </p:spPr>
+        <p:style>
+          <a:lnRef idx="1">
+            <a:schemeClr val="accent1"/>
+          </a:lnRef>
+          <a:fillRef idx="3">
+            <a:schemeClr val="accent1"/>
+          </a:fillRef>
+          <a:effectRef idx="2">
+            <a:schemeClr val="accent1"/>
+          </a:effectRef>
+          <a:fontRef idx="minor">
+            <a:schemeClr val="lt1"/>
+          </a:fontRef>
+        </p:style>
+        <p:txBody>
+          <a:bodyPr rtlCol="0" anchor="ctr"/>
+          <a:lstStyle/>
+          <a:p>
+            <a:pPr algn="ctr"/>
+          </a:p>
+        </p:txBody>
+      </p:sp>
+      <p:sp>
+        <p:nvSpPr>
+          <p:cNvPr id="19" name="TextBox 18"/>
+          <p:cNvSpPr txBox="1"/>
+          <p:nvPr/>
+        </p:nvSpPr>
+        <p:spPr>
+          <a:xfrm>
+            <a:off x="5029200" y="3108960"/>
+            <a:ext cx="640080" cy="320040"/>
+          </a:xfrm>
+          <a:prstGeom prst="rect">
+            <a:avLst/>
+          </a:prstGeom>
+          <a:noFill/>
+        </p:spPr>
+        <p:txBody>
+          <a:bodyPr wrap="square" anchor="t" lIns="0" rIns="0" tIns="0" bIns="0">
+            <a:spAutoFit/>
+          </a:bodyPr>
+          <a:lstStyle/>
+          <a:p>
+            <a:pPr algn="l" rtl="1">
+              <a:lnSpc>
+                <a:spcPct val="120000"/>
+              </a:lnSpc>
+            </a:pPr>
+            <a:r>
+              <a:rPr sz="1300" b="1">
+                <a:solidFill>
+                  <a:srgbClr val="0B6B3A"/>
+                </a:solidFill>
+                <a:latin typeface="Segoe UI"/>
+              </a:rPr>
+              <a:t>١:١٠</a:t>
+            </a:r>
+          </a:p>
+        </p:txBody>
+      </p:sp>
+      <p:sp>
+        <p:nvSpPr>
+          <p:cNvPr id="20" name="TextBox 19"/>
+          <p:cNvSpPr txBox="1"/>
+          <p:nvPr/>
+        </p:nvSpPr>
+        <p:spPr>
+          <a:xfrm>
+            <a:off x="850392" y="3108960"/>
+            <a:ext cx="4069080" cy="320040"/>
+          </a:xfrm>
+          <a:prstGeom prst="rect">
+            <a:avLst/>
+          </a:prstGeom>
+          <a:noFill/>
+        </p:spPr>
+        <p:txBody>
+          <a:bodyPr wrap="square" anchor="t" lIns="0" rIns="0" tIns="0" bIns="0">
+            <a:spAutoFit/>
+          </a:bodyPr>
+          <a:lstStyle/>
+          <a:p>
+            <a:pPr algn="r" rtl="1">
+              <a:lnSpc>
+                <a:spcPct val="120000"/>
+              </a:lnSpc>
+            </a:pPr>
+            <a:r>
+              <a:rPr sz="1700" b="1">
+                <a:solidFill>
+                  <a:srgbClr val="101613"/>
+                </a:solidFill>
+                <a:latin typeface="Segoe UI"/>
+              </a:rPr>
+              <a:t>«ابدأ المشي»</a:t>
+            </a:r>
+          </a:p>
+        </p:txBody>
+      </p:sp>
+      <p:sp>
+        <p:nvSpPr>
+          <p:cNvPr id="21" name="TextBox 20"/>
+          <p:cNvSpPr txBox="1"/>
+          <p:nvPr/>
+        </p:nvSpPr>
+        <p:spPr>
+          <a:xfrm>
+            <a:off x="850392" y="3456432"/>
+            <a:ext cx="4754880" cy="365760"/>
+          </a:xfrm>
+          <a:prstGeom prst="rect">
+            <a:avLst/>
+          </a:prstGeom>
+          <a:noFill/>
+        </p:spPr>
+        <p:txBody>
+          <a:bodyPr wrap="square" anchor="t" lIns="0" rIns="0" tIns="0" bIns="0">
+            <a:spAutoFit/>
+          </a:bodyPr>
+          <a:lstStyle/>
+          <a:p>
+            <a:pPr algn="r" rtl="1">
+              <a:lnSpc>
+                <a:spcPct val="120000"/>
+              </a:lnSpc>
+            </a:pPr>
+            <a:r>
+              <a:rPr sz="1200" b="0">
+                <a:solidFill>
+                  <a:srgbClr val="5B6B63"/>
+                </a:solidFill>
+                <a:latin typeface="Segoe UI"/>
+              </a:rPr>
+              <a:t>إرشاد حقيقي + اهتزاز يمين/يسار — امشِ أمامهم</a:t>
+            </a:r>
+          </a:p>
+        </p:txBody>
+      </p:sp>
+      <p:sp>
+        <p:nvSpPr>
+          <p:cNvPr id="22" name="Rounded Rectangle 21"/>
+          <p:cNvSpPr/>
+          <p:nvPr/>
+        </p:nvSpPr>
+        <p:spPr>
+          <a:xfrm>
+            <a:off x="6309360" y="4078224"/>
+            <a:ext cx="5120640" cy="914400"/>
+          </a:xfrm>
+          <a:prstGeom prst="roundRect">
+            <a:avLst>
+              <a:gd name="adj" fmla="val 12000"/>
+            </a:avLst>
+          </a:prstGeom>
+          <a:solidFill>
+            <a:srgbClr val="F4F7F5"/>
+          </a:solidFill>
+          <a:ln w="12700">
+            <a:solidFill>
+              <a:srgbClr val="D8E2DC"/>
+            </a:solidFill>
+          </a:ln>
+          <a:effectLst/>
+        </p:spPr>
+        <p:style>
+          <a:lnRef idx="1">
+            <a:schemeClr val="accent1"/>
+          </a:lnRef>
+          <a:fillRef idx="3">
+            <a:schemeClr val="accent1"/>
+          </a:fillRef>
+          <a:effectRef idx="2">
+            <a:schemeClr val="accent1"/>
+          </a:effectRef>
+          <a:fontRef idx="minor">
+            <a:schemeClr val="lt1"/>
+          </a:fontRef>
+        </p:style>
+        <p:txBody>
+          <a:bodyPr rtlCol="0" anchor="ctr"/>
+          <a:lstStyle/>
+          <a:p>
+            <a:pPr algn="ctr"/>
+          </a:p>
+        </p:txBody>
+      </p:sp>
+      <p:sp>
+        <p:nvSpPr>
+          <p:cNvPr id="23" name="TextBox 22"/>
+          <p:cNvSpPr txBox="1"/>
+          <p:nvPr/>
+        </p:nvSpPr>
+        <p:spPr>
+          <a:xfrm>
+            <a:off x="10652760" y="4187952"/>
+            <a:ext cx="640080" cy="320040"/>
+          </a:xfrm>
+          <a:prstGeom prst="rect">
+            <a:avLst/>
+          </a:prstGeom>
+          <a:noFill/>
+        </p:spPr>
+        <p:txBody>
+          <a:bodyPr wrap="square" anchor="t" lIns="0" rIns="0" tIns="0" bIns="0">
+            <a:spAutoFit/>
+          </a:bodyPr>
+          <a:lstStyle/>
+          <a:p>
+            <a:pPr algn="l" rtl="1">
+              <a:lnSpc>
+                <a:spcPct val="120000"/>
+              </a:lnSpc>
+            </a:pPr>
+            <a:r>
+              <a:rPr sz="1300" b="1">
+                <a:solidFill>
+                  <a:srgbClr val="0B6B3A"/>
+                </a:solidFill>
+                <a:latin typeface="Segoe UI"/>
+              </a:rPr>
+              <a:t>١:٤٠</a:t>
+            </a:r>
+          </a:p>
+        </p:txBody>
+      </p:sp>
+      <p:sp>
+        <p:nvSpPr>
+          <p:cNvPr id="24" name="TextBox 23"/>
+          <p:cNvSpPr txBox="1"/>
+          <p:nvPr/>
+        </p:nvSpPr>
+        <p:spPr>
+          <a:xfrm>
+            <a:off x="6473952" y="4187952"/>
+            <a:ext cx="4069080" cy="320040"/>
+          </a:xfrm>
+          <a:prstGeom prst="rect">
+            <a:avLst/>
+          </a:prstGeom>
+          <a:noFill/>
+        </p:spPr>
+        <p:txBody>
+          <a:bodyPr wrap="square" anchor="t" lIns="0" rIns="0" tIns="0" bIns="0">
+            <a:spAutoFit/>
+          </a:bodyPr>
+          <a:lstStyle/>
+          <a:p>
+            <a:pPr algn="r" rtl="1">
+              <a:lnSpc>
+                <a:spcPct val="120000"/>
+              </a:lnSpc>
+            </a:pPr>
+            <a:r>
+              <a:rPr sz="1700" b="1">
+                <a:solidFill>
+                  <a:srgbClr val="101613"/>
+                </a:solidFill>
+                <a:latin typeface="Segoe UI"/>
+              </a:rPr>
+              <a:t>أطفئ الواي فاي</a:t>
+            </a:r>
+          </a:p>
+        </p:txBody>
+      </p:sp>
+      <p:sp>
+        <p:nvSpPr>
+          <p:cNvPr id="25" name="TextBox 24"/>
+          <p:cNvSpPr txBox="1"/>
+          <p:nvPr/>
+        </p:nvSpPr>
+        <p:spPr>
+          <a:xfrm>
+            <a:off x="6473952" y="4535424"/>
+            <a:ext cx="4754880" cy="365760"/>
+          </a:xfrm>
+          <a:prstGeom prst="rect">
+            <a:avLst/>
+          </a:prstGeom>
+          <a:noFill/>
+        </p:spPr>
+        <p:txBody>
+          <a:bodyPr wrap="square" anchor="t" lIns="0" rIns="0" tIns="0" bIns="0">
+            <a:spAutoFit/>
+          </a:bodyPr>
+          <a:lstStyle/>
+          <a:p>
+            <a:pPr algn="r" rtl="1">
+              <a:lnSpc>
+                <a:spcPct val="120000"/>
+              </a:lnSpc>
+            </a:pPr>
+            <a:r>
+              <a:rPr sz="1200" b="0">
+                <a:solidFill>
+                  <a:srgbClr val="5B6B63"/>
+                </a:solidFill>
+                <a:latin typeface="Segoe UI"/>
+              </a:rPr>
+              <a:t>التطبيق يستمر — «أوفلاين»</a:t>
+            </a:r>
+          </a:p>
+        </p:txBody>
+      </p:sp>
+      <p:sp>
+        <p:nvSpPr>
+          <p:cNvPr id="26" name="Rounded Rectangle 25"/>
+          <p:cNvSpPr/>
+          <p:nvPr/>
+        </p:nvSpPr>
+        <p:spPr>
+          <a:xfrm>
+            <a:off x="685800" y="4078224"/>
+            <a:ext cx="5120640" cy="914400"/>
+          </a:xfrm>
+          <a:prstGeom prst="roundRect">
+            <a:avLst>
+              <a:gd name="adj" fmla="val 12000"/>
+            </a:avLst>
+          </a:prstGeom>
+          <a:solidFill>
+            <a:srgbClr val="F4F7F5"/>
+          </a:solidFill>
+          <a:ln w="12700">
+            <a:solidFill>
+              <a:srgbClr val="D8E2DC"/>
+            </a:solidFill>
+          </a:ln>
+          <a:effectLst/>
+        </p:spPr>
+        <p:style>
+          <a:lnRef idx="1">
+            <a:schemeClr val="accent1"/>
+          </a:lnRef>
+          <a:fillRef idx="3">
+            <a:schemeClr val="accent1"/>
+          </a:fillRef>
+          <a:effectRef idx="2">
+            <a:schemeClr val="accent1"/>
+          </a:effectRef>
+          <a:fontRef idx="minor">
+            <a:schemeClr val="lt1"/>
+          </a:fontRef>
+        </p:style>
+        <p:txBody>
+          <a:bodyPr rtlCol="0" anchor="ctr"/>
+          <a:lstStyle/>
+          <a:p>
+            <a:pPr algn="ctr"/>
+          </a:p>
+        </p:txBody>
+      </p:sp>
+      <p:sp>
+        <p:nvSpPr>
+          <p:cNvPr id="27" name="TextBox 26"/>
+          <p:cNvSpPr txBox="1"/>
+          <p:nvPr/>
+        </p:nvSpPr>
+        <p:spPr>
+          <a:xfrm>
+            <a:off x="5029200" y="4187952"/>
+            <a:ext cx="640080" cy="320040"/>
+          </a:xfrm>
+          <a:prstGeom prst="rect">
+            <a:avLst/>
+          </a:prstGeom>
+          <a:noFill/>
+        </p:spPr>
+        <p:txBody>
+          <a:bodyPr wrap="square" anchor="t" lIns="0" rIns="0" tIns="0" bIns="0">
+            <a:spAutoFit/>
+          </a:bodyPr>
+          <a:lstStyle/>
+          <a:p>
+            <a:pPr algn="l" rtl="1">
+              <a:lnSpc>
+                <a:spcPct val="120000"/>
+              </a:lnSpc>
+            </a:pPr>
+            <a:r>
+              <a:rPr sz="1300" b="1">
+                <a:solidFill>
+                  <a:srgbClr val="0B6B3A"/>
+                </a:solidFill>
+                <a:latin typeface="Segoe UI"/>
+              </a:rPr>
+              <a:t>٢:٠٠</a:t>
+            </a:r>
+          </a:p>
+        </p:txBody>
+      </p:sp>
+      <p:sp>
+        <p:nvSpPr>
+          <p:cNvPr id="28" name="TextBox 27"/>
+          <p:cNvSpPr txBox="1"/>
+          <p:nvPr/>
+        </p:nvSpPr>
+        <p:spPr>
+          <a:xfrm>
+            <a:off x="850392" y="4187952"/>
+            <a:ext cx="4069080" cy="320040"/>
+          </a:xfrm>
+          <a:prstGeom prst="rect">
+            <a:avLst/>
+          </a:prstGeom>
+          <a:noFill/>
+        </p:spPr>
+        <p:txBody>
+          <a:bodyPr wrap="square" anchor="t" lIns="0" rIns="0" tIns="0" bIns="0">
+            <a:spAutoFit/>
+          </a:bodyPr>
+          <a:lstStyle/>
+          <a:p>
+            <a:pPr algn="r" rtl="1">
+              <a:lnSpc>
+                <a:spcPct val="120000"/>
+              </a:lnSpc>
+            </a:pPr>
+            <a:r>
+              <a:rPr sz="1700" b="1">
+                <a:solidFill>
+                  <a:srgbClr val="101613"/>
+                </a:solidFill>
+                <a:latin typeface="Segoe UI"/>
+              </a:rPr>
+              <a:t>بلّغ عن عائق بصوتك</a:t>
+            </a:r>
+          </a:p>
+        </p:txBody>
+      </p:sp>
+      <p:sp>
+        <p:nvSpPr>
+          <p:cNvPr id="29" name="TextBox 28"/>
+          <p:cNvSpPr txBox="1"/>
+          <p:nvPr/>
+        </p:nvSpPr>
+        <p:spPr>
+          <a:xfrm>
+            <a:off x="850392" y="4535424"/>
+            <a:ext cx="4754880" cy="365760"/>
+          </a:xfrm>
+          <a:prstGeom prst="rect">
+            <a:avLst/>
+          </a:prstGeom>
+          <a:noFill/>
+        </p:spPr>
+        <p:txBody>
+          <a:bodyPr wrap="square" anchor="t" lIns="0" rIns="0" tIns="0" bIns="0">
+            <a:spAutoFit/>
+          </a:bodyPr>
+          <a:lstStyle/>
+          <a:p>
+            <a:pPr algn="r" rtl="1">
+              <a:lnSpc>
+                <a:spcPct val="120000"/>
+              </a:lnSpc>
+            </a:pPr>
+            <a:r>
+              <a:rPr sz="1200" b="0">
+                <a:solidFill>
+                  <a:srgbClr val="5B6B63"/>
+                </a:solidFill>
+                <a:latin typeface="Segoe UI"/>
+              </a:rPr>
+              <a:t>يُحفظ محليًا ويُرفع لاحقًا</a:t>
+            </a:r>
+          </a:p>
+        </p:txBody>
+      </p:sp>
+      <p:sp>
+        <p:nvSpPr>
+          <p:cNvPr id="30" name="Rounded Rectangle 29"/>
+          <p:cNvSpPr/>
+          <p:nvPr/>
+        </p:nvSpPr>
+        <p:spPr>
+          <a:xfrm>
+            <a:off x="6309360" y="5157216"/>
+            <a:ext cx="5120640" cy="914400"/>
+          </a:xfrm>
+          <a:prstGeom prst="roundRect">
+            <a:avLst>
+              <a:gd name="adj" fmla="val 12000"/>
+            </a:avLst>
+          </a:prstGeom>
+          <a:solidFill>
+            <a:srgbClr val="F4F7F5"/>
+          </a:solidFill>
+          <a:ln w="12700">
+            <a:solidFill>
+              <a:srgbClr val="D8E2DC"/>
+            </a:solidFill>
+          </a:ln>
+          <a:effectLst/>
+        </p:spPr>
+        <p:style>
+          <a:lnRef idx="1">
+            <a:schemeClr val="accent1"/>
+          </a:lnRef>
+          <a:fillRef idx="3">
+            <a:schemeClr val="accent1"/>
+          </a:fillRef>
+          <a:effectRef idx="2">
+            <a:schemeClr val="accent1"/>
+          </a:effectRef>
+          <a:fontRef idx="minor">
+            <a:schemeClr val="lt1"/>
+          </a:fontRef>
+        </p:style>
+        <p:txBody>
+          <a:bodyPr rtlCol="0" anchor="ctr"/>
+          <a:lstStyle/>
+          <a:p>
+            <a:pPr algn="ctr"/>
+          </a:p>
+        </p:txBody>
+      </p:sp>
+      <p:sp>
+        <p:nvSpPr>
+          <p:cNvPr id="31" name="TextBox 30"/>
+          <p:cNvSpPr txBox="1"/>
+          <p:nvPr/>
+        </p:nvSpPr>
+        <p:spPr>
+          <a:xfrm>
+            <a:off x="10652760" y="5266944"/>
+            <a:ext cx="640080" cy="320040"/>
+          </a:xfrm>
+          <a:prstGeom prst="rect">
+            <a:avLst/>
+          </a:prstGeom>
+          <a:noFill/>
+        </p:spPr>
+        <p:txBody>
+          <a:bodyPr wrap="square" anchor="t" lIns="0" rIns="0" tIns="0" bIns="0">
+            <a:spAutoFit/>
+          </a:bodyPr>
+          <a:lstStyle/>
+          <a:p>
+            <a:pPr algn="l" rtl="1">
+              <a:lnSpc>
+                <a:spcPct val="120000"/>
+              </a:lnSpc>
+            </a:pPr>
+            <a:r>
+              <a:rPr sz="1300" b="1">
+                <a:solidFill>
+                  <a:srgbClr val="0B6B3A"/>
+                </a:solidFill>
+                <a:latin typeface="Segoe UI"/>
+              </a:rPr>
+              <a:t>٢:٢٠</a:t>
+            </a:r>
+          </a:p>
+        </p:txBody>
+      </p:sp>
+      <p:sp>
+        <p:nvSpPr>
+          <p:cNvPr id="32" name="TextBox 31"/>
+          <p:cNvSpPr txBox="1"/>
+          <p:nvPr/>
+        </p:nvSpPr>
+        <p:spPr>
+          <a:xfrm>
+            <a:off x="6473952" y="5266944"/>
+            <a:ext cx="4069080" cy="320040"/>
+          </a:xfrm>
+          <a:prstGeom prst="rect">
+            <a:avLst/>
+          </a:prstGeom>
+          <a:noFill/>
+        </p:spPr>
+        <p:txBody>
+          <a:bodyPr wrap="square" anchor="t" lIns="0" rIns="0" tIns="0" bIns="0">
+            <a:spAutoFit/>
+          </a:bodyPr>
+          <a:lstStyle/>
+          <a:p>
+            <a:pPr algn="r" rtl="1">
+              <a:lnSpc>
+                <a:spcPct val="120000"/>
+              </a:lnSpc>
+            </a:pPr>
+            <a:r>
+              <a:rPr sz="1700" b="1">
+                <a:solidFill>
+                  <a:srgbClr val="101613"/>
+                </a:solidFill>
+                <a:latin typeface="Segoe UI"/>
+              </a:rPr>
+              <a:t>زر الاستغاثة</a:t>
+            </a:r>
+          </a:p>
+        </p:txBody>
+      </p:sp>
+      <p:sp>
+        <p:nvSpPr>
+          <p:cNvPr id="33" name="TextBox 32"/>
+          <p:cNvSpPr txBox="1"/>
+          <p:nvPr/>
+        </p:nvSpPr>
+        <p:spPr>
+          <a:xfrm>
+            <a:off x="6473952" y="5614416"/>
+            <a:ext cx="4754880" cy="365760"/>
+          </a:xfrm>
+          <a:prstGeom prst="rect">
+            <a:avLst/>
+          </a:prstGeom>
+          <a:noFill/>
+        </p:spPr>
+        <p:txBody>
+          <a:bodyPr wrap="square" anchor="t" lIns="0" rIns="0" tIns="0" bIns="0">
+            <a:spAutoFit/>
+          </a:bodyPr>
+          <a:lstStyle/>
+          <a:p>
+            <a:pPr algn="r" rtl="1">
+              <a:lnSpc>
+                <a:spcPct val="120000"/>
+              </a:lnSpc>
+            </a:pPr>
+            <a:r>
+              <a:rPr sz="1200" b="0">
+                <a:solidFill>
+                  <a:srgbClr val="5B6B63"/>
+                </a:solidFill>
+                <a:latin typeface="Segoe UI"/>
+              </a:rPr>
+              <a:t>عدّ تنازلي ثم إلغاء بنقرة</a:t>
+            </a:r>
+          </a:p>
+        </p:txBody>
+      </p:sp>
+      <p:sp>
+        <p:nvSpPr>
+          <p:cNvPr id="34" name="Rounded Rectangle 33"/>
+          <p:cNvSpPr/>
+          <p:nvPr/>
+        </p:nvSpPr>
+        <p:spPr>
+          <a:xfrm>
+            <a:off x="685800" y="5157216"/>
+            <a:ext cx="5120640" cy="914400"/>
+          </a:xfrm>
+          <a:prstGeom prst="roundRect">
+            <a:avLst>
+              <a:gd name="adj" fmla="val 12000"/>
+            </a:avLst>
+          </a:prstGeom>
+          <a:solidFill>
+            <a:srgbClr val="F4F7F5"/>
+          </a:solidFill>
+          <a:ln w="12700">
+            <a:solidFill>
+              <a:srgbClr val="D8E2DC"/>
+            </a:solidFill>
+          </a:ln>
+          <a:effectLst/>
+        </p:spPr>
+        <p:style>
+          <a:lnRef idx="1">
+            <a:schemeClr val="accent1"/>
+          </a:lnRef>
+          <a:fillRef idx="3">
+            <a:schemeClr val="accent1"/>
+          </a:fillRef>
+          <a:effectRef idx="2">
+            <a:schemeClr val="accent1"/>
+          </a:effectRef>
+          <a:fontRef idx="minor">
+            <a:schemeClr val="lt1"/>
+          </a:fontRef>
+        </p:style>
+        <p:txBody>
+          <a:bodyPr rtlCol="0" anchor="ctr"/>
+          <a:lstStyle/>
+          <a:p>
+            <a:pPr algn="ctr"/>
+          </a:p>
+        </p:txBody>
+      </p:sp>
+      <p:sp>
+        <p:nvSpPr>
+          <p:cNvPr id="35" name="TextBox 34"/>
+          <p:cNvSpPr txBox="1"/>
+          <p:nvPr/>
+        </p:nvSpPr>
+        <p:spPr>
+          <a:xfrm>
+            <a:off x="5029200" y="5266944"/>
+            <a:ext cx="640080" cy="320040"/>
+          </a:xfrm>
+          <a:prstGeom prst="rect">
+            <a:avLst/>
+          </a:prstGeom>
+          <a:noFill/>
+        </p:spPr>
+        <p:txBody>
+          <a:bodyPr wrap="square" anchor="t" lIns="0" rIns="0" tIns="0" bIns="0">
+            <a:spAutoFit/>
+          </a:bodyPr>
+          <a:lstStyle/>
+          <a:p>
+            <a:pPr algn="l" rtl="1">
+              <a:lnSpc>
+                <a:spcPct val="120000"/>
+              </a:lnSpc>
+            </a:pPr>
+            <a:r>
+              <a:rPr sz="1300" b="1">
+                <a:solidFill>
+                  <a:srgbClr val="0B6B3A"/>
+                </a:solidFill>
+                <a:latin typeface="Segoe UI"/>
+              </a:rPr>
+              <a:t>٢:٤٠</a:t>
+            </a:r>
+          </a:p>
+        </p:txBody>
+      </p:sp>
+      <p:sp>
+        <p:nvSpPr>
+          <p:cNvPr id="36" name="TextBox 35"/>
+          <p:cNvSpPr txBox="1"/>
+          <p:nvPr/>
+        </p:nvSpPr>
+        <p:spPr>
+          <a:xfrm>
+            <a:off x="850392" y="5266944"/>
+            <a:ext cx="4069080" cy="320040"/>
+          </a:xfrm>
+          <a:prstGeom prst="rect">
+            <a:avLst/>
+          </a:prstGeom>
+          <a:noFill/>
+        </p:spPr>
+        <p:txBody>
+          <a:bodyPr wrap="square" anchor="t" lIns="0" rIns="0" tIns="0" bIns="0">
+            <a:spAutoFit/>
+          </a:bodyPr>
+          <a:lstStyle/>
+          <a:p>
+            <a:pPr algn="r" rtl="1">
+              <a:lnSpc>
+                <a:spcPct val="120000"/>
+              </a:lnSpc>
+            </a:pPr>
+            <a:r>
+              <a:rPr sz="1700" b="1">
+                <a:solidFill>
+                  <a:srgbClr val="101613"/>
+                </a:solidFill>
+                <a:latin typeface="Segoe UI"/>
+              </a:rPr>
+              <a:t>الخاتمة</a:t>
+            </a:r>
+          </a:p>
+        </p:txBody>
+      </p:sp>
+      <p:sp>
+        <p:nvSpPr>
+          <p:cNvPr id="37" name="TextBox 36"/>
+          <p:cNvSpPr txBox="1"/>
+          <p:nvPr/>
+        </p:nvSpPr>
+        <p:spPr>
+          <a:xfrm>
+            <a:off x="850392" y="5614416"/>
+            <a:ext cx="4754880" cy="365760"/>
+          </a:xfrm>
+          <a:prstGeom prst="rect">
+            <a:avLst/>
+          </a:prstGeom>
+          <a:noFill/>
+        </p:spPr>
+        <p:txBody>
+          <a:bodyPr wrap="square" anchor="t" lIns="0" rIns="0" tIns="0" bIns="0">
+            <a:spAutoFit/>
+          </a:bodyPr>
+          <a:lstStyle/>
+          <a:p>
+            <a:pPr algn="r" rtl="1">
+              <a:lnSpc>
+                <a:spcPct val="120000"/>
+              </a:lnSpc>
+            </a:pPr>
+            <a:r>
+              <a:rPr sz="1200" b="0">
+                <a:solidFill>
+                  <a:srgbClr val="5B6B63"/>
+                </a:solidFill>
+                <a:latin typeface="Segoe UI"/>
+              </a:rPr>
+              <a:t>استقلالية، لا شرائح</a:t>
+            </a:r>
+          </a:p>
+        </p:txBody>
+      </p:sp>
+    </p:spTree>
+  </p:cSld>
+  <p:clrMapOvr>
+    <a:masterClrMapping/>
+  </p:clrMapOvr>
+</p:sld>
+</file>
+
+<file path=ppt/slides/slide15.xml><?xml version="1.0" encoding="utf-8"?>
+<p:sld xmlns:a="http://schemas.openxmlformats.org/drawingml/2006/main" xmlns:p="http://schemas.openxmlformats.org/presentationml/2006/main" xmlns:r="http://schemas.openxmlformats.org/officeDocument/2006/relationships">
+  <p:cSld>
+    <p:spTree>
+      <p:nvGrpSpPr>
+        <p:cNvPr id="1" name=""/>
+        <p:cNvGrpSpPr/>
+        <p:nvPr/>
+      </p:nvGrpSpPr>
+      <p:grpSpPr/>
+      <p:sp>
+        <p:nvSpPr>
+          <p:cNvPr id="2" name="Rectangle 1"/>
+          <p:cNvSpPr/>
+          <p:nvPr/>
+        </p:nvSpPr>
+        <p:spPr>
+          <a:xfrm>
+            <a:off x="0" y="0"/>
+            <a:ext cx="12191695" cy="146304"/>
+          </a:xfrm>
+          <a:prstGeom prst="rect">
+            <a:avLst/>
+          </a:prstGeom>
+          <a:solidFill>
+            <a:srgbClr val="0B6B3A"/>
+          </a:solidFill>
+          <a:ln>
+            <a:noFill/>
+          </a:ln>
+          <a:effectLst/>
+        </p:spPr>
+        <p:style>
+          <a:lnRef idx="1">
+            <a:schemeClr val="accent1"/>
+          </a:lnRef>
+          <a:fillRef idx="3">
+            <a:schemeClr val="accent1"/>
+          </a:fillRef>
+          <a:effectRef idx="2">
+            <a:schemeClr val="accent1"/>
+          </a:effectRef>
+          <a:fontRef idx="minor">
+            <a:schemeClr val="lt1"/>
+          </a:fontRef>
+        </p:style>
+        <p:txBody>
+          <a:bodyPr rtlCol="0" anchor="ctr"/>
+          <a:lstStyle/>
+          <a:p>
+            <a:pPr algn="ctr"/>
+          </a:p>
+        </p:txBody>
+      </p:sp>
+      <p:sp>
+        <p:nvSpPr>
+          <p:cNvPr id="3" name="TextBox 2"/>
+          <p:cNvSpPr txBox="1"/>
+          <p:nvPr/>
+        </p:nvSpPr>
+        <p:spPr>
+          <a:xfrm>
+            <a:off x="640080" y="411480"/>
+            <a:ext cx="10972800" cy="365760"/>
+          </a:xfrm>
+          <a:prstGeom prst="rect">
+            <a:avLst/>
+          </a:prstGeom>
+          <a:noFill/>
+        </p:spPr>
+        <p:txBody>
+          <a:bodyPr wrap="square" anchor="t" lIns="0" rIns="0" tIns="0" bIns="0">
+            <a:spAutoFit/>
+          </a:bodyPr>
+          <a:lstStyle/>
+          <a:p>
+            <a:pPr algn="r" rtl="1">
+              <a:lnSpc>
+                <a:spcPct val="120000"/>
+              </a:lnSpc>
+            </a:pPr>
+            <a:r>
+              <a:rPr sz="1400" b="1">
+                <a:solidFill>
+                  <a:srgbClr val="F5A524"/>
+                </a:solidFill>
+                <a:latin typeface="Segoe UI"/>
+              </a:rPr>
+              <a:t>الابتكار · الأثر · التنفيذ · الاستدامة</a:t>
+            </a:r>
+          </a:p>
+        </p:txBody>
+      </p:sp>
+      <p:sp>
+        <p:nvSpPr>
+          <p:cNvPr id="4" name="TextBox 3"/>
+          <p:cNvSpPr txBox="1"/>
+          <p:nvPr/>
+        </p:nvSpPr>
+        <p:spPr>
+          <a:xfrm>
+            <a:off x="640080" y="731520"/>
+            <a:ext cx="10972800" cy="822960"/>
+          </a:xfrm>
+          <a:prstGeom prst="rect">
+            <a:avLst/>
+          </a:prstGeom>
+          <a:noFill/>
+        </p:spPr>
+        <p:txBody>
+          <a:bodyPr wrap="square" anchor="t" lIns="0" rIns="0" tIns="0" bIns="0">
+            <a:spAutoFit/>
+          </a:bodyPr>
+          <a:lstStyle/>
+          <a:p>
+            <a:pPr algn="r" rtl="1">
+              <a:lnSpc>
+                <a:spcPct val="120000"/>
+              </a:lnSpc>
+            </a:pPr>
+            <a:r>
+              <a:rPr sz="3400" b="1">
+                <a:solidFill>
+                  <a:srgbClr val="101613"/>
+                </a:solidFill>
+                <a:latin typeface="Segoe UI"/>
+              </a:rPr>
+              <a:t>لماذا يفوز هذا المشروع؟</a:t>
+            </a:r>
+          </a:p>
+        </p:txBody>
+      </p:sp>
+      <p:sp>
+        <p:nvSpPr>
+          <p:cNvPr id="5" name="Rectangle 4"/>
+          <p:cNvSpPr/>
+          <p:nvPr/>
+        </p:nvSpPr>
+        <p:spPr>
+          <a:xfrm>
+            <a:off x="10088575" y="1600200"/>
+            <a:ext cx="1463040" cy="54864"/>
+          </a:xfrm>
+          <a:prstGeom prst="rect">
+            <a:avLst/>
+          </a:prstGeom>
+          <a:solidFill>
+            <a:srgbClr val="0B6B3A"/>
+          </a:solidFill>
+          <a:ln>
+            <a:noFill/>
+          </a:ln>
+          <a:effectLst/>
+        </p:spPr>
+        <p:style>
+          <a:lnRef idx="1">
+            <a:schemeClr val="accent1"/>
+          </a:lnRef>
+          <a:fillRef idx="3">
+            <a:schemeClr val="accent1"/>
+          </a:fillRef>
+          <a:effectRef idx="2">
+            <a:schemeClr val="accent1"/>
+          </a:effectRef>
+          <a:fontRef idx="minor">
+            <a:schemeClr val="lt1"/>
+          </a:fontRef>
+        </p:style>
+        <p:txBody>
+          <a:bodyPr rtlCol="0" anchor="ctr"/>
+          <a:lstStyle/>
+          <a:p>
+            <a:pPr algn="ctr"/>
+          </a:p>
+        </p:txBody>
+      </p:sp>
+      <p:sp>
+        <p:nvSpPr>
+          <p:cNvPr id="6" name="Rounded Rectangle 5"/>
+          <p:cNvSpPr/>
+          <p:nvPr/>
+        </p:nvSpPr>
+        <p:spPr>
+          <a:xfrm>
+            <a:off x="640080" y="1965960"/>
+            <a:ext cx="2194560" cy="868680"/>
+          </a:xfrm>
+          <a:prstGeom prst="roundRect">
+            <a:avLst>
+              <a:gd name="adj" fmla="val 18000"/>
+            </a:avLst>
+          </a:prstGeom>
+          <a:solidFill>
+            <a:srgbClr val="0B6B3A"/>
+          </a:solidFill>
+          <a:ln>
+            <a:noFill/>
+          </a:ln>
+          <a:effectLst/>
+        </p:spPr>
+        <p:style>
+          <a:lnRef idx="1">
+            <a:schemeClr val="accent1"/>
+          </a:lnRef>
+          <a:fillRef idx="3">
+            <a:schemeClr val="accent1"/>
+          </a:fillRef>
+          <a:effectRef idx="2">
+            <a:schemeClr val="accent1"/>
+          </a:effectRef>
+          <a:fontRef idx="minor">
+            <a:schemeClr val="lt1"/>
+          </a:fontRef>
+        </p:style>
+        <p:txBody>
+          <a:bodyPr rtlCol="0" anchor="ctr"/>
+          <a:lstStyle/>
+          <a:p>
+            <a:pPr algn="ctr"/>
+          </a:p>
+        </p:txBody>
+      </p:sp>
+      <p:sp>
+        <p:nvSpPr>
+          <p:cNvPr id="7" name="TextBox 6"/>
+          <p:cNvSpPr txBox="1"/>
+          <p:nvPr/>
+        </p:nvSpPr>
+        <p:spPr>
+          <a:xfrm>
+            <a:off x="640080" y="2185416"/>
+            <a:ext cx="2194560" cy="411480"/>
+          </a:xfrm>
+          <a:prstGeom prst="rect">
+            <a:avLst/>
+          </a:prstGeom>
+          <a:noFill/>
+        </p:spPr>
+        <p:txBody>
+          <a:bodyPr wrap="square" anchor="t" lIns="0" rIns="0" tIns="0" bIns="0">
+            <a:spAutoFit/>
+          </a:bodyPr>
+          <a:lstStyle/>
+          <a:p>
+            <a:pPr algn="ctr" rtl="1">
+              <a:lnSpc>
+                <a:spcPct val="120000"/>
+              </a:lnSpc>
+            </a:pPr>
+            <a:r>
+              <a:rPr sz="1900" b="1">
+                <a:solidFill>
+                  <a:srgbClr val="FFFFFF"/>
+                </a:solidFill>
+                <a:latin typeface="Segoe UI"/>
+              </a:rPr>
+              <a:t>الابتكار</a:t>
+            </a:r>
+          </a:p>
+        </p:txBody>
+      </p:sp>
+      <p:sp>
+        <p:nvSpPr>
+          <p:cNvPr id="8" name="TextBox 7"/>
+          <p:cNvSpPr txBox="1"/>
+          <p:nvPr/>
+        </p:nvSpPr>
+        <p:spPr>
+          <a:xfrm>
+            <a:off x="3063240" y="2075688"/>
+            <a:ext cx="8412480" cy="685800"/>
+          </a:xfrm>
+          <a:prstGeom prst="rect">
+            <a:avLst/>
+          </a:prstGeom>
+          <a:noFill/>
+        </p:spPr>
+        <p:txBody>
+          <a:bodyPr wrap="square" anchor="t" lIns="0" rIns="0" tIns="0" bIns="0">
+            <a:spAutoFit/>
+          </a:bodyPr>
+          <a:lstStyle/>
+          <a:p>
+            <a:pPr algn="r" rtl="1">
+              <a:lnSpc>
+                <a:spcPct val="135000"/>
+              </a:lnSpc>
+            </a:pPr>
+            <a:r>
+              <a:rPr sz="1500" b="0">
+                <a:solidFill>
+                  <a:srgbClr val="101613"/>
+                </a:solidFill>
+                <a:latin typeface="Segoe UI"/>
+              </a:rPr>
+              <a:t>أول تطبيق عربي صوتي أولًا يجمع: إرشاد + إشارات + بلاغات + SOS + أوفلاين في منتج واحد</a:t>
+            </a:r>
+          </a:p>
+        </p:txBody>
+      </p:sp>
+      <p:sp>
+        <p:nvSpPr>
+          <p:cNvPr id="9" name="Rounded Rectangle 8"/>
+          <p:cNvSpPr/>
+          <p:nvPr/>
+        </p:nvSpPr>
+        <p:spPr>
+          <a:xfrm>
+            <a:off x="640080" y="3108960"/>
+            <a:ext cx="2194560" cy="868680"/>
+          </a:xfrm>
+          <a:prstGeom prst="roundRect">
+            <a:avLst>
+              <a:gd name="adj" fmla="val 18000"/>
+            </a:avLst>
+          </a:prstGeom>
+          <a:solidFill>
+            <a:srgbClr val="0B6B3A"/>
+          </a:solidFill>
+          <a:ln>
+            <a:noFill/>
+          </a:ln>
+          <a:effectLst/>
+        </p:spPr>
+        <p:style>
+          <a:lnRef idx="1">
+            <a:schemeClr val="accent1"/>
+          </a:lnRef>
+          <a:fillRef idx="3">
+            <a:schemeClr val="accent1"/>
+          </a:fillRef>
+          <a:effectRef idx="2">
+            <a:schemeClr val="accent1"/>
+          </a:effectRef>
+          <a:fontRef idx="minor">
+            <a:schemeClr val="lt1"/>
+          </a:fontRef>
+        </p:style>
+        <p:txBody>
+          <a:bodyPr rtlCol="0" anchor="ctr"/>
+          <a:lstStyle/>
+          <a:p>
+            <a:pPr algn="ctr"/>
+          </a:p>
+        </p:txBody>
+      </p:sp>
+      <p:sp>
+        <p:nvSpPr>
+          <p:cNvPr id="10" name="TextBox 9"/>
+          <p:cNvSpPr txBox="1"/>
+          <p:nvPr/>
+        </p:nvSpPr>
+        <p:spPr>
+          <a:xfrm>
+            <a:off x="640080" y="3328416"/>
+            <a:ext cx="2194560" cy="411480"/>
+          </a:xfrm>
+          <a:prstGeom prst="rect">
+            <a:avLst/>
+          </a:prstGeom>
+          <a:noFill/>
+        </p:spPr>
+        <p:txBody>
+          <a:bodyPr wrap="square" anchor="t" lIns="0" rIns="0" tIns="0" bIns="0">
+            <a:spAutoFit/>
+          </a:bodyPr>
+          <a:lstStyle/>
+          <a:p>
+            <a:pPr algn="ctr" rtl="1">
+              <a:lnSpc>
+                <a:spcPct val="120000"/>
+              </a:lnSpc>
+            </a:pPr>
+            <a:r>
+              <a:rPr sz="1900" b="1">
+                <a:solidFill>
+                  <a:srgbClr val="FFFFFF"/>
+                </a:solidFill>
+                <a:latin typeface="Segoe UI"/>
+              </a:rPr>
+              <a:t>الأثر</a:t>
+            </a:r>
+          </a:p>
+        </p:txBody>
+      </p:sp>
+      <p:sp>
+        <p:nvSpPr>
+          <p:cNvPr id="11" name="TextBox 10"/>
+          <p:cNvSpPr txBox="1"/>
+          <p:nvPr/>
+        </p:nvSpPr>
+        <p:spPr>
+          <a:xfrm>
+            <a:off x="3063240" y="3218688"/>
+            <a:ext cx="8412480" cy="685800"/>
+          </a:xfrm>
+          <a:prstGeom prst="rect">
+            <a:avLst/>
+          </a:prstGeom>
+          <a:noFill/>
+        </p:spPr>
+        <p:txBody>
+          <a:bodyPr wrap="square" anchor="t" lIns="0" rIns="0" tIns="0" bIns="0">
+            <a:spAutoFit/>
+          </a:bodyPr>
+          <a:lstStyle/>
+          <a:p>
+            <a:pPr algn="r" rtl="1">
+              <a:lnSpc>
+                <a:spcPct val="135000"/>
+              </a:lnSpc>
+            </a:pPr>
+            <a:r>
+              <a:rPr sz="1500" b="0">
+                <a:solidFill>
+                  <a:srgbClr val="101613"/>
+                </a:solidFill>
+                <a:latin typeface="Segoe UI"/>
+              </a:rPr>
+              <a:t>يستهدف فئة مهمّشة بمشكلة موثّقة، وحل مبني على مقابلات لا على تخمين</a:t>
+            </a:r>
+          </a:p>
+        </p:txBody>
+      </p:sp>
+      <p:sp>
+        <p:nvSpPr>
+          <p:cNvPr id="12" name="Rounded Rectangle 11"/>
+          <p:cNvSpPr/>
+          <p:nvPr/>
+        </p:nvSpPr>
+        <p:spPr>
+          <a:xfrm>
+            <a:off x="640080" y="4251960"/>
+            <a:ext cx="2194560" cy="868680"/>
+          </a:xfrm>
+          <a:prstGeom prst="roundRect">
+            <a:avLst>
+              <a:gd name="adj" fmla="val 18000"/>
+            </a:avLst>
+          </a:prstGeom>
+          <a:solidFill>
+            <a:srgbClr val="0B6B3A"/>
+          </a:solidFill>
+          <a:ln>
+            <a:noFill/>
+          </a:ln>
+          <a:effectLst/>
+        </p:spPr>
+        <p:style>
+          <a:lnRef idx="1">
+            <a:schemeClr val="accent1"/>
+          </a:lnRef>
+          <a:fillRef idx="3">
+            <a:schemeClr val="accent1"/>
+          </a:fillRef>
+          <a:effectRef idx="2">
+            <a:schemeClr val="accent1"/>
+          </a:effectRef>
+          <a:fontRef idx="minor">
+            <a:schemeClr val="lt1"/>
+          </a:fontRef>
+        </p:style>
+        <p:txBody>
+          <a:bodyPr rtlCol="0" anchor="ctr"/>
+          <a:lstStyle/>
+          <a:p>
+            <a:pPr algn="ctr"/>
+          </a:p>
+        </p:txBody>
+      </p:sp>
+      <p:sp>
+        <p:nvSpPr>
+          <p:cNvPr id="13" name="TextBox 12"/>
+          <p:cNvSpPr txBox="1"/>
+          <p:nvPr/>
+        </p:nvSpPr>
+        <p:spPr>
+          <a:xfrm>
+            <a:off x="640080" y="4471416"/>
+            <a:ext cx="2194560" cy="411480"/>
+          </a:xfrm>
+          <a:prstGeom prst="rect">
+            <a:avLst/>
+          </a:prstGeom>
+          <a:noFill/>
+        </p:spPr>
+        <p:txBody>
+          <a:bodyPr wrap="square" anchor="t" lIns="0" rIns="0" tIns="0" bIns="0">
+            <a:spAutoFit/>
+          </a:bodyPr>
+          <a:lstStyle/>
+          <a:p>
+            <a:pPr algn="ctr" rtl="1">
+              <a:lnSpc>
+                <a:spcPct val="120000"/>
+              </a:lnSpc>
+            </a:pPr>
+            <a:r>
+              <a:rPr sz="1900" b="1">
+                <a:solidFill>
+                  <a:srgbClr val="FFFFFF"/>
+                </a:solidFill>
+                <a:latin typeface="Segoe UI"/>
+              </a:rPr>
+              <a:t>التنفيذ</a:t>
+            </a:r>
+          </a:p>
+        </p:txBody>
+      </p:sp>
+      <p:sp>
+        <p:nvSpPr>
+          <p:cNvPr id="14" name="TextBox 13"/>
+          <p:cNvSpPr txBox="1"/>
+          <p:nvPr/>
+        </p:nvSpPr>
+        <p:spPr>
+          <a:xfrm>
+            <a:off x="3063240" y="4361688"/>
+            <a:ext cx="8412480" cy="685800"/>
+          </a:xfrm>
+          <a:prstGeom prst="rect">
+            <a:avLst/>
+          </a:prstGeom>
+          <a:noFill/>
+        </p:spPr>
+        <p:txBody>
+          <a:bodyPr wrap="square" anchor="t" lIns="0" rIns="0" tIns="0" bIns="0">
+            <a:spAutoFit/>
+          </a:bodyPr>
+          <a:lstStyle/>
+          <a:p>
+            <a:pPr algn="r" rtl="1">
+              <a:lnSpc>
+                <a:spcPct val="135000"/>
+              </a:lnSpc>
+            </a:pPr>
+            <a:r>
+              <a:rPr sz="1500" b="0">
+                <a:solidFill>
+                  <a:srgbClr val="101613"/>
+                </a:solidFill>
+                <a:latin typeface="Segoe UI"/>
+              </a:rPr>
+              <a:t>53 ملف Dart · 61 اختبارًا ناجحًا · تحليل بلا أخطاء · يعمل الآن على الويب</a:t>
+            </a:r>
+          </a:p>
+        </p:txBody>
+      </p:sp>
+      <p:sp>
+        <p:nvSpPr>
+          <p:cNvPr id="15" name="Rounded Rectangle 14"/>
+          <p:cNvSpPr/>
+          <p:nvPr/>
+        </p:nvSpPr>
+        <p:spPr>
+          <a:xfrm>
+            <a:off x="640080" y="5394960"/>
+            <a:ext cx="2194560" cy="868680"/>
+          </a:xfrm>
+          <a:prstGeom prst="roundRect">
+            <a:avLst>
+              <a:gd name="adj" fmla="val 18000"/>
+            </a:avLst>
+          </a:prstGeom>
+          <a:solidFill>
+            <a:srgbClr val="0B6B3A"/>
+          </a:solidFill>
+          <a:ln>
+            <a:noFill/>
+          </a:ln>
+          <a:effectLst/>
+        </p:spPr>
+        <p:style>
+          <a:lnRef idx="1">
+            <a:schemeClr val="accent1"/>
+          </a:lnRef>
+          <a:fillRef idx="3">
+            <a:schemeClr val="accent1"/>
+          </a:fillRef>
+          <a:effectRef idx="2">
+            <a:schemeClr val="accent1"/>
+          </a:effectRef>
+          <a:fontRef idx="minor">
+            <a:schemeClr val="lt1"/>
+          </a:fontRef>
+        </p:style>
+        <p:txBody>
+          <a:bodyPr rtlCol="0" anchor="ctr"/>
+          <a:lstStyle/>
+          <a:p>
+            <a:pPr algn="ctr"/>
+          </a:p>
+        </p:txBody>
+      </p:sp>
+      <p:sp>
+        <p:nvSpPr>
+          <p:cNvPr id="16" name="TextBox 15"/>
+          <p:cNvSpPr txBox="1"/>
+          <p:nvPr/>
+        </p:nvSpPr>
+        <p:spPr>
+          <a:xfrm>
+            <a:off x="640080" y="5614416"/>
+            <a:ext cx="2194560" cy="411480"/>
+          </a:xfrm>
+          <a:prstGeom prst="rect">
+            <a:avLst/>
+          </a:prstGeom>
+          <a:noFill/>
+        </p:spPr>
+        <p:txBody>
+          <a:bodyPr wrap="square" anchor="t" lIns="0" rIns="0" tIns="0" bIns="0">
+            <a:spAutoFit/>
+          </a:bodyPr>
+          <a:lstStyle/>
+          <a:p>
+            <a:pPr algn="ctr" rtl="1">
+              <a:lnSpc>
+                <a:spcPct val="120000"/>
+              </a:lnSpc>
+            </a:pPr>
+            <a:r>
+              <a:rPr sz="1900" b="1">
+                <a:solidFill>
+                  <a:srgbClr val="FFFFFF"/>
+                </a:solidFill>
+                <a:latin typeface="Segoe UI"/>
+              </a:rPr>
+              <a:t>الاستدامة</a:t>
+            </a:r>
+          </a:p>
+        </p:txBody>
+      </p:sp>
+      <p:sp>
+        <p:nvSpPr>
+          <p:cNvPr id="17" name="TextBox 16"/>
+          <p:cNvSpPr txBox="1"/>
+          <p:nvPr/>
+        </p:nvSpPr>
+        <p:spPr>
+          <a:xfrm>
+            <a:off x="3063240" y="5504688"/>
+            <a:ext cx="8412480" cy="685800"/>
+          </a:xfrm>
+          <a:prstGeom prst="rect">
+            <a:avLst/>
+          </a:prstGeom>
+          <a:noFill/>
+        </p:spPr>
+        <p:txBody>
+          <a:bodyPr wrap="square" anchor="t" lIns="0" rIns="0" tIns="0" bIns="0">
+            <a:spAutoFit/>
+          </a:bodyPr>
+          <a:lstStyle/>
+          <a:p>
+            <a:pPr algn="r" rtl="1">
+              <a:lnSpc>
+                <a:spcPct val="135000"/>
+              </a:lnSpc>
+            </a:pPr>
+            <a:r>
+              <a:rPr sz="1500" b="0">
+                <a:solidFill>
+                  <a:srgbClr val="101613"/>
+                </a:solidFill>
+                <a:latin typeface="Segoe UI"/>
+              </a:rPr>
+              <a:t>مفتوح المصدر · بلا تكاليف تشغيل · قابل للتوسّع لـ Beacons والذكاء الاصطناعي</a:t>
+            </a:r>
+          </a:p>
+        </p:txBody>
+      </p:sp>
+      <p:sp>
+        <p:nvSpPr>
+          <p:cNvPr id="18" name="TextBox 17"/>
+          <p:cNvSpPr txBox="1"/>
+          <p:nvPr/>
+        </p:nvSpPr>
+        <p:spPr>
+          <a:xfrm>
+            <a:off x="640080" y="6309360"/>
+            <a:ext cx="10972800" cy="365760"/>
+          </a:xfrm>
+          <a:prstGeom prst="rect">
+            <a:avLst/>
+          </a:prstGeom>
+          <a:noFill/>
+        </p:spPr>
+        <p:txBody>
+          <a:bodyPr wrap="square" anchor="t" lIns="0" rIns="0" tIns="0" bIns="0">
+            <a:spAutoFit/>
+          </a:bodyPr>
+          <a:lstStyle/>
+          <a:p>
+            <a:pPr algn="r" rtl="1">
+              <a:lnSpc>
+                <a:spcPct val="120000"/>
+              </a:lnSpc>
+            </a:pPr>
+            <a:r>
+              <a:rPr sz="1300" b="1">
+                <a:solidFill>
+                  <a:srgbClr val="0B6B3A"/>
+                </a:solidFill>
+                <a:latin typeface="Segoe UI"/>
+              </a:rPr>
+              <a:t>كل رقم مذكور قابل للتحقق من المستودع مباشرة أمام اللجنة.</a:t>
             </a:r>
           </a:p>
         </p:txBody>

</xml_diff>